<commit_message>
extra 1 + extra 2 redactado
</commit_message>
<xml_diff>
--- a/LabBook_20.pptx
+++ b/LabBook_20.pptx
@@ -5,10 +5,10 @@
     <p:sldMasterId id="2147483648" r:id="rId1"/>
   </p:sldMasterIdLst>
   <p:notesMasterIdLst>
-    <p:notesMasterId r:id="rId30"/>
+    <p:notesMasterId r:id="rId32"/>
   </p:notesMasterIdLst>
   <p:handoutMasterIdLst>
-    <p:handoutMasterId r:id="rId31"/>
+    <p:handoutMasterId r:id="rId33"/>
   </p:handoutMasterIdLst>
   <p:sldIdLst>
     <p:sldId id="256" r:id="rId2"/>
@@ -35,10 +35,12 @@
     <p:sldId id="301" r:id="rId23"/>
     <p:sldId id="315" r:id="rId24"/>
     <p:sldId id="290" r:id="rId25"/>
-    <p:sldId id="297" r:id="rId26"/>
-    <p:sldId id="292" r:id="rId27"/>
-    <p:sldId id="298" r:id="rId28"/>
-    <p:sldId id="288" r:id="rId29"/>
+    <p:sldId id="316" r:id="rId26"/>
+    <p:sldId id="297" r:id="rId27"/>
+    <p:sldId id="317" r:id="rId28"/>
+    <p:sldId id="292" r:id="rId29"/>
+    <p:sldId id="298" r:id="rId30"/>
+    <p:sldId id="288" r:id="rId31"/>
   </p:sldIdLst>
   <p:sldSz cx="12192000" cy="6858000"/>
   <p:notesSz cx="12192000" cy="6858000"/>
@@ -829,7 +831,7 @@
           <a:p>
             <a:fld id="{8438F8DC-35B0-48E6-A86E-42F1F08DD00F}" type="datetimeFigureOut">
               <a:rPr lang="es-ES" smtClean="0"/>
-              <a:t>27/04/2026</a:t>
+              <a:t>29/04/2026</a:t>
             </a:fld>
             <a:endParaRPr lang="es-ES"/>
           </a:p>
@@ -1006,7 +1008,7 @@
           <a:p>
             <a:fld id="{FACBDC12-F39B-4B97-8F4D-6734F9D366FF}" type="datetimeFigureOut">
               <a:rPr lang="es-ES" smtClean="0"/>
-              <a:t>27/04/2026</a:t>
+              <a:t>29/04/2026</a:t>
             </a:fld>
             <a:endParaRPr lang="es-ES"/>
           </a:p>
@@ -2637,6 +2639,114 @@
         <p:cNvPr id="1" name="">
           <a:extLst>
             <a:ext uri="{FF2B5EF4-FFF2-40B4-BE49-F238E27FC236}">
+              <a16:creationId xmlns:a16="http://schemas.microsoft.com/office/drawing/2014/main" id="{FD363820-3581-F8D2-8EFF-C97772868F16}"/>
+            </a:ext>
+          </a:extLst>
+        </p:cNvPr>
+        <p:cNvGrpSpPr/>
+        <p:nvPr/>
+      </p:nvGrpSpPr>
+      <p:grpSpPr>
+        <a:xfrm>
+          <a:off x="0" y="0"/>
+          <a:ext cx="0" cy="0"/>
+          <a:chOff x="0" y="0"/>
+          <a:chExt cx="0" cy="0"/>
+        </a:xfrm>
+      </p:grpSpPr>
+      <p:sp>
+        <p:nvSpPr>
+          <p:cNvPr id="2" name="Marcador de imagen de diapositiva 1">
+            <a:extLst>
+              <a:ext uri="{FF2B5EF4-FFF2-40B4-BE49-F238E27FC236}">
+                <a16:creationId xmlns:a16="http://schemas.microsoft.com/office/drawing/2014/main" id="{F84D89D2-BECC-DD50-EC7D-5E64C468632D}"/>
+              </a:ext>
+            </a:extLst>
+          </p:cNvPr>
+          <p:cNvSpPr>
+            <a:spLocks noGrp="1" noRot="1" noChangeAspect="1"/>
+          </p:cNvSpPr>
+          <p:nvPr>
+            <p:ph type="sldImg"/>
+          </p:nvPr>
+        </p:nvSpPr>
+        <p:spPr/>
+      </p:sp>
+      <p:sp>
+        <p:nvSpPr>
+          <p:cNvPr id="3" name="Marcador de notas 2">
+            <a:extLst>
+              <a:ext uri="{FF2B5EF4-FFF2-40B4-BE49-F238E27FC236}">
+                <a16:creationId xmlns:a16="http://schemas.microsoft.com/office/drawing/2014/main" id="{9FE1EEC2-F2C0-404F-5D55-081E5B86127A}"/>
+              </a:ext>
+            </a:extLst>
+          </p:cNvPr>
+          <p:cNvSpPr>
+            <a:spLocks noGrp="1"/>
+          </p:cNvSpPr>
+          <p:nvPr>
+            <p:ph type="body" idx="1"/>
+          </p:nvPr>
+        </p:nvSpPr>
+        <p:spPr/>
+        <p:txBody>
+          <a:bodyPr/>
+          <a:lstStyle/>
+          <a:p>
+            <a:endParaRPr lang="es-ES" dirty="0"/>
+          </a:p>
+        </p:txBody>
+      </p:sp>
+      <p:sp>
+        <p:nvSpPr>
+          <p:cNvPr id="4" name="Marcador de número de diapositiva 3">
+            <a:extLst>
+              <a:ext uri="{FF2B5EF4-FFF2-40B4-BE49-F238E27FC236}">
+                <a16:creationId xmlns:a16="http://schemas.microsoft.com/office/drawing/2014/main" id="{2B4FF7EE-D814-FD95-0985-1DD43576A390}"/>
+              </a:ext>
+            </a:extLst>
+          </p:cNvPr>
+          <p:cNvSpPr>
+            <a:spLocks noGrp="1"/>
+          </p:cNvSpPr>
+          <p:nvPr>
+            <p:ph type="sldNum" sz="quarter" idx="5"/>
+          </p:nvPr>
+        </p:nvSpPr>
+        <p:spPr/>
+        <p:txBody>
+          <a:bodyPr/>
+          <a:lstStyle/>
+          <a:p>
+            <a:fld id="{676223B9-C868-4436-87D9-1A3152E1157A}" type="slidenum">
+              <a:rPr lang="es-ES" smtClean="0"/>
+              <a:t>25</a:t>
+            </a:fld>
+            <a:endParaRPr lang="es-ES"/>
+          </a:p>
+        </p:txBody>
+      </p:sp>
+    </p:spTree>
+    <p:extLst>
+      <p:ext uri="{BB962C8B-B14F-4D97-AF65-F5344CB8AC3E}">
+        <p14:creationId xmlns:p14="http://schemas.microsoft.com/office/powerpoint/2010/main" val="2580943197"/>
+      </p:ext>
+    </p:extLst>
+  </p:cSld>
+  <p:clrMapOvr>
+    <a:masterClrMapping/>
+  </p:clrMapOvr>
+</p:notes>
+</file>
+
+<file path=ppt/notesSlides/notesSlide22.xml><?xml version="1.0" encoding="utf-8"?>
+<p:notes xmlns:a="http://schemas.openxmlformats.org/drawingml/2006/main" xmlns:r="http://schemas.openxmlformats.org/officeDocument/2006/relationships" xmlns:p="http://schemas.openxmlformats.org/presentationml/2006/main">
+  <p:cSld>
+    <p:spTree>
+      <p:nvGrpSpPr>
+        <p:cNvPr id="1" name="">
+          <a:extLst>
+            <a:ext uri="{FF2B5EF4-FFF2-40B4-BE49-F238E27FC236}">
               <a16:creationId xmlns:a16="http://schemas.microsoft.com/office/drawing/2014/main" id="{1AC9112F-7FB7-4F49-F4F6-C1D0DC6ADBEE}"/>
             </a:ext>
           </a:extLst>
@@ -2718,7 +2828,7 @@
           <a:p>
             <a:fld id="{676223B9-C868-4436-87D9-1A3152E1157A}" type="slidenum">
               <a:rPr lang="es-ES" smtClean="0"/>
-              <a:t>25</a:t>
+              <a:t>26</a:t>
             </a:fld>
             <a:endParaRPr lang="es-ES"/>
           </a:p>
@@ -2737,7 +2847,115 @@
 </p:notes>
 </file>
 
-<file path=ppt/notesSlides/notesSlide22.xml><?xml version="1.0" encoding="utf-8"?>
+<file path=ppt/notesSlides/notesSlide23.xml><?xml version="1.0" encoding="utf-8"?>
+<p:notes xmlns:a="http://schemas.openxmlformats.org/drawingml/2006/main" xmlns:r="http://schemas.openxmlformats.org/officeDocument/2006/relationships" xmlns:p="http://schemas.openxmlformats.org/presentationml/2006/main">
+  <p:cSld>
+    <p:spTree>
+      <p:nvGrpSpPr>
+        <p:cNvPr id="1" name="">
+          <a:extLst>
+            <a:ext uri="{FF2B5EF4-FFF2-40B4-BE49-F238E27FC236}">
+              <a16:creationId xmlns:a16="http://schemas.microsoft.com/office/drawing/2014/main" id="{11308689-919D-C6D1-23DB-9D443034FEF5}"/>
+            </a:ext>
+          </a:extLst>
+        </p:cNvPr>
+        <p:cNvGrpSpPr/>
+        <p:nvPr/>
+      </p:nvGrpSpPr>
+      <p:grpSpPr>
+        <a:xfrm>
+          <a:off x="0" y="0"/>
+          <a:ext cx="0" cy="0"/>
+          <a:chOff x="0" y="0"/>
+          <a:chExt cx="0" cy="0"/>
+        </a:xfrm>
+      </p:grpSpPr>
+      <p:sp>
+        <p:nvSpPr>
+          <p:cNvPr id="2" name="Marcador de imagen de diapositiva 1">
+            <a:extLst>
+              <a:ext uri="{FF2B5EF4-FFF2-40B4-BE49-F238E27FC236}">
+                <a16:creationId xmlns:a16="http://schemas.microsoft.com/office/drawing/2014/main" id="{E6EC498C-71FA-B367-1AF8-849444AB2038}"/>
+              </a:ext>
+            </a:extLst>
+          </p:cNvPr>
+          <p:cNvSpPr>
+            <a:spLocks noGrp="1" noRot="1" noChangeAspect="1"/>
+          </p:cNvSpPr>
+          <p:nvPr>
+            <p:ph type="sldImg"/>
+          </p:nvPr>
+        </p:nvSpPr>
+        <p:spPr/>
+      </p:sp>
+      <p:sp>
+        <p:nvSpPr>
+          <p:cNvPr id="3" name="Marcador de notas 2">
+            <a:extLst>
+              <a:ext uri="{FF2B5EF4-FFF2-40B4-BE49-F238E27FC236}">
+                <a16:creationId xmlns:a16="http://schemas.microsoft.com/office/drawing/2014/main" id="{925AD165-93C6-0949-D5A3-47E7E7E96A9F}"/>
+              </a:ext>
+            </a:extLst>
+          </p:cNvPr>
+          <p:cNvSpPr>
+            <a:spLocks noGrp="1"/>
+          </p:cNvSpPr>
+          <p:nvPr>
+            <p:ph type="body" idx="1"/>
+          </p:nvPr>
+        </p:nvSpPr>
+        <p:spPr/>
+        <p:txBody>
+          <a:bodyPr/>
+          <a:lstStyle/>
+          <a:p>
+            <a:endParaRPr lang="es-ES" dirty="0"/>
+          </a:p>
+        </p:txBody>
+      </p:sp>
+      <p:sp>
+        <p:nvSpPr>
+          <p:cNvPr id="4" name="Marcador de número de diapositiva 3">
+            <a:extLst>
+              <a:ext uri="{FF2B5EF4-FFF2-40B4-BE49-F238E27FC236}">
+                <a16:creationId xmlns:a16="http://schemas.microsoft.com/office/drawing/2014/main" id="{765B6FFD-F2B4-58A2-A274-518A8E06A7E0}"/>
+              </a:ext>
+            </a:extLst>
+          </p:cNvPr>
+          <p:cNvSpPr>
+            <a:spLocks noGrp="1"/>
+          </p:cNvSpPr>
+          <p:nvPr>
+            <p:ph type="sldNum" sz="quarter" idx="5"/>
+          </p:nvPr>
+        </p:nvSpPr>
+        <p:spPr/>
+        <p:txBody>
+          <a:bodyPr/>
+          <a:lstStyle/>
+          <a:p>
+            <a:fld id="{676223B9-C868-4436-87D9-1A3152E1157A}" type="slidenum">
+              <a:rPr lang="es-ES" smtClean="0"/>
+              <a:t>27</a:t>
+            </a:fld>
+            <a:endParaRPr lang="es-ES"/>
+          </a:p>
+        </p:txBody>
+      </p:sp>
+    </p:spTree>
+    <p:extLst>
+      <p:ext uri="{BB962C8B-B14F-4D97-AF65-F5344CB8AC3E}">
+        <p14:creationId xmlns:p14="http://schemas.microsoft.com/office/powerpoint/2010/main" val="4025047709"/>
+      </p:ext>
+    </p:extLst>
+  </p:cSld>
+  <p:clrMapOvr>
+    <a:masterClrMapping/>
+  </p:clrMapOvr>
+</p:notes>
+</file>
+
+<file path=ppt/notesSlides/notesSlide24.xml><?xml version="1.0" encoding="utf-8"?>
 <p:notes xmlns:a="http://schemas.openxmlformats.org/drawingml/2006/main" xmlns:r="http://schemas.openxmlformats.org/officeDocument/2006/relationships" xmlns:p="http://schemas.openxmlformats.org/presentationml/2006/main">
   <p:cSld>
     <p:spTree>
@@ -2826,7 +3044,7 @@
           <a:p>
             <a:fld id="{676223B9-C868-4436-87D9-1A3152E1157A}" type="slidenum">
               <a:rPr lang="es-ES" smtClean="0"/>
-              <a:t>26</a:t>
+              <a:t>28</a:t>
             </a:fld>
             <a:endParaRPr lang="es-ES"/>
           </a:p>
@@ -2845,7 +3063,7 @@
 </p:notes>
 </file>
 
-<file path=ppt/notesSlides/notesSlide23.xml><?xml version="1.0" encoding="utf-8"?>
+<file path=ppt/notesSlides/notesSlide25.xml><?xml version="1.0" encoding="utf-8"?>
 <p:notes xmlns:a="http://schemas.openxmlformats.org/drawingml/2006/main" xmlns:r="http://schemas.openxmlformats.org/officeDocument/2006/relationships" xmlns:p="http://schemas.openxmlformats.org/presentationml/2006/main">
   <p:cSld>
     <p:spTree>
@@ -2934,7 +3152,7 @@
           <a:p>
             <a:fld id="{676223B9-C868-4436-87D9-1A3152E1157A}" type="slidenum">
               <a:rPr lang="es-ES" smtClean="0"/>
-              <a:t>27</a:t>
+              <a:t>29</a:t>
             </a:fld>
             <a:endParaRPr lang="es-ES"/>
           </a:p>
@@ -9872,8 +10090,8 @@
           </a:p>
         </p:txBody>
       </p:sp>
-      <mc:AlternateContent xmlns:mc="http://schemas.openxmlformats.org/markup-compatibility/2006">
-        <mc:Choice xmlns:a14="http://schemas.microsoft.com/office/drawing/2010/main" Requires="a14">
+      <mc:AlternateContent xmlns:mc="http://schemas.openxmlformats.org/markup-compatibility/2006" xmlns:a14="http://schemas.microsoft.com/office/drawing/2010/main">
+        <mc:Choice Requires="a14">
           <p:sp>
             <p:nvSpPr>
               <p:cNvPr id="2" name="CuadroTexto 1">
@@ -10933,7 +11151,7 @@
             </p:txBody>
           </p:sp>
         </mc:Choice>
-        <mc:Fallback>
+        <mc:Fallback xmlns="">
           <p:sp>
             <p:nvSpPr>
               <p:cNvPr id="2" name="CuadroTexto 1">
@@ -15528,8 +15746,8 @@
           </a:p>
         </p:txBody>
       </p:sp>
-      <mc:AlternateContent xmlns:mc="http://schemas.openxmlformats.org/markup-compatibility/2006">
-        <mc:Choice xmlns:a14="http://schemas.microsoft.com/office/drawing/2010/main" Requires="a14">
+      <mc:AlternateContent xmlns:mc="http://schemas.openxmlformats.org/markup-compatibility/2006" xmlns:a14="http://schemas.microsoft.com/office/drawing/2010/main">
+        <mc:Choice Requires="a14">
           <p:sp>
             <p:nvSpPr>
               <p:cNvPr id="2" name="CuadroTexto 1">
@@ -16020,7 +16238,7 @@
                     <m:sSub>
                       <m:sSubPr>
                         <m:ctrlPr>
-                          <a:rPr lang="ar-AE" sz="1000">
+                          <a:rPr lang="ar-AE" sz="1000" i="1">
                             <a:latin typeface="Cambria Math" panose="02040503050406030204" pitchFamily="18" charset="0"/>
                           </a:rPr>
                         </m:ctrlPr>
@@ -16077,7 +16295,7 @@
                     <m:f>
                       <m:fPr>
                         <m:ctrlPr>
-                          <a:rPr lang="ar-AE" sz="1000">
+                          <a:rPr lang="ar-AE" sz="1000" i="1">
                             <a:latin typeface="Cambria Math" panose="02040503050406030204" pitchFamily="18" charset="0"/>
                           </a:rPr>
                         </m:ctrlPr>
@@ -16102,7 +16320,7 @@
                     <m:sSub>
                       <m:sSubPr>
                         <m:ctrlPr>
-                          <a:rPr lang="ar-AE" sz="1000">
+                          <a:rPr lang="ar-AE" sz="1000" i="1">
                             <a:latin typeface="Cambria Math" panose="02040503050406030204" pitchFamily="18" charset="0"/>
                           </a:rPr>
                         </m:ctrlPr>
@@ -16324,7 +16542,7 @@
             </p:txBody>
           </p:sp>
         </mc:Choice>
-        <mc:Fallback>
+        <mc:Fallback xmlns="">
           <p:sp>
             <p:nvSpPr>
               <p:cNvPr id="2" name="CuadroTexto 1">
@@ -16582,82 +16800,6 @@
       </p:sp>
       <p:sp>
         <p:nvSpPr>
-          <p:cNvPr id="2" name="CuadroTexto 1">
-            <a:extLst>
-              <a:ext uri="{FF2B5EF4-FFF2-40B4-BE49-F238E27FC236}">
-                <a16:creationId xmlns:a16="http://schemas.microsoft.com/office/drawing/2014/main" id="{D0F8CF3B-B920-DBFC-F825-0C87B51EADA7}"/>
-              </a:ext>
-            </a:extLst>
-          </p:cNvPr>
-          <p:cNvSpPr txBox="1"/>
-          <p:nvPr/>
-        </p:nvSpPr>
-        <p:spPr>
-          <a:xfrm>
-            <a:off x="609441" y="4860334"/>
-            <a:ext cx="11199971" cy="1015663"/>
-          </a:xfrm>
-          <a:prstGeom prst="rect">
-            <a:avLst/>
-          </a:prstGeom>
-          <a:solidFill>
-            <a:schemeClr val="bg1">
-              <a:lumMod val="95000"/>
-            </a:schemeClr>
-          </a:solidFill>
-          <a:ln w="28575">
-            <a:solidFill>
-              <a:srgbClr val="E0700D"/>
-            </a:solidFill>
-          </a:ln>
-        </p:spPr>
-        <p:txBody>
-          <a:bodyPr wrap="square" rtlCol="0">
-            <a:spAutoFit/>
-          </a:bodyPr>
-          <a:lstStyle/>
-          <a:p>
-            <a:pPr algn="just"/>
-            <a:r>
-              <a:rPr lang="en-US" sz="1200" dirty="0">
-                <a:latin typeface="Arial" panose="020B0604020202020204" pitchFamily="34" charset="0"/>
-                <a:cs typeface="Arial" panose="020B0604020202020204" pitchFamily="34" charset="0"/>
-              </a:rPr>
-              <a:t>Make conclusions and observations from your results</a:t>
-            </a:r>
-          </a:p>
-          <a:p>
-            <a:pPr algn="just"/>
-            <a:endParaRPr lang="en-US" sz="1200" dirty="0">
-              <a:latin typeface="Arial" panose="020B0604020202020204" pitchFamily="34" charset="0"/>
-              <a:cs typeface="Arial" panose="020B0604020202020204" pitchFamily="34" charset="0"/>
-            </a:endParaRPr>
-          </a:p>
-          <a:p>
-            <a:pPr algn="just"/>
-            <a:endParaRPr lang="en-US" sz="1200" dirty="0">
-              <a:latin typeface="Arial" panose="020B0604020202020204" pitchFamily="34" charset="0"/>
-              <a:cs typeface="Arial" panose="020B0604020202020204" pitchFamily="34" charset="0"/>
-            </a:endParaRPr>
-          </a:p>
-          <a:p>
-            <a:pPr algn="just"/>
-            <a:endParaRPr lang="en-US" sz="1200" dirty="0">
-              <a:latin typeface="Arial" panose="020B0604020202020204" pitchFamily="34" charset="0"/>
-              <a:cs typeface="Arial" panose="020B0604020202020204" pitchFamily="34" charset="0"/>
-            </a:endParaRPr>
-          </a:p>
-          <a:p>
-            <a:pPr algn="just"/>
-            <a:endParaRPr lang="en-US" sz="1200" dirty="0">
-              <a:latin typeface="Arial" panose="020B0604020202020204" pitchFamily="34" charset="0"/>
-              <a:cs typeface="Arial" panose="020B0604020202020204" pitchFamily="34" charset="0"/>
-            </a:endParaRPr>
-          </a:p>
-        </p:txBody>
-      </p:sp>
-      <p:sp>
-        <p:nvSpPr>
           <p:cNvPr id="5" name="Rectángulo 4">
             <a:extLst>
               <a:ext uri="{FF2B5EF4-FFF2-40B4-BE49-F238E27FC236}">
@@ -16760,42 +16902,6 @@
           </a:p>
         </p:txBody>
       </p:sp>
-      <p:sp>
-        <p:nvSpPr>
-          <p:cNvPr id="7" name="CuadroTexto 6">
-            <a:extLst>
-              <a:ext uri="{FF2B5EF4-FFF2-40B4-BE49-F238E27FC236}">
-                <a16:creationId xmlns:a16="http://schemas.microsoft.com/office/drawing/2014/main" id="{6D309BFB-98FD-0CBA-3C6A-346D8859893B}"/>
-              </a:ext>
-            </a:extLst>
-          </p:cNvPr>
-          <p:cNvSpPr txBox="1"/>
-          <p:nvPr/>
-        </p:nvSpPr>
-        <p:spPr>
-          <a:xfrm>
-            <a:off x="6331152" y="4342178"/>
-            <a:ext cx="2269787" cy="369332"/>
-          </a:xfrm>
-          <a:prstGeom prst="rect">
-            <a:avLst/>
-          </a:prstGeom>
-          <a:noFill/>
-        </p:spPr>
-        <p:txBody>
-          <a:bodyPr wrap="square">
-            <a:spAutoFit/>
-          </a:bodyPr>
-          <a:lstStyle/>
-          <a:p>
-            <a:r>
-              <a:rPr lang="en-US" dirty="0"/>
-              <a:t>slab = 150nm</a:t>
-            </a:r>
-            <a:endParaRPr lang="es-ES" dirty="0"/>
-          </a:p>
-        </p:txBody>
-      </p:sp>
       <mc:AlternateContent xmlns:mc="http://schemas.openxmlformats.org/markup-compatibility/2006" xmlns:a14="http://schemas.microsoft.com/office/drawing/2010/main">
         <mc:Choice Requires="a14">
           <p:sp>
@@ -17060,6 +17166,66 @@
           </p:sp>
         </mc:Fallback>
       </mc:AlternateContent>
+      <p:pic>
+        <p:nvPicPr>
+          <p:cNvPr id="10" name="Imagen 9">
+            <a:extLst>
+              <a:ext uri="{FF2B5EF4-FFF2-40B4-BE49-F238E27FC236}">
+                <a16:creationId xmlns:a16="http://schemas.microsoft.com/office/drawing/2014/main" id="{EDA44C1E-8688-AC34-01A5-54163625980D}"/>
+              </a:ext>
+            </a:extLst>
+          </p:cNvPr>
+          <p:cNvPicPr>
+            <a:picLocks noChangeAspect="1"/>
+          </p:cNvPicPr>
+          <p:nvPr/>
+        </p:nvPicPr>
+        <p:blipFill>
+          <a:blip r:embed="rId7"/>
+          <a:stretch>
+            <a:fillRect/>
+          </a:stretch>
+        </p:blipFill>
+        <p:spPr>
+          <a:xfrm>
+            <a:off x="1310422" y="1538273"/>
+            <a:ext cx="4084595" cy="3125082"/>
+          </a:xfrm>
+          <a:prstGeom prst="rect">
+            <a:avLst/>
+          </a:prstGeom>
+        </p:spPr>
+      </p:pic>
+      <p:pic>
+        <p:nvPicPr>
+          <p:cNvPr id="12" name="Imagen 11">
+            <a:extLst>
+              <a:ext uri="{FF2B5EF4-FFF2-40B4-BE49-F238E27FC236}">
+                <a16:creationId xmlns:a16="http://schemas.microsoft.com/office/drawing/2014/main" id="{95A741F0-2A7E-84DA-9167-F91851BF2E91}"/>
+              </a:ext>
+            </a:extLst>
+          </p:cNvPr>
+          <p:cNvPicPr>
+            <a:picLocks noChangeAspect="1"/>
+          </p:cNvPicPr>
+          <p:nvPr/>
+        </p:nvPicPr>
+        <p:blipFill>
+          <a:blip r:embed="rId8"/>
+          <a:stretch>
+            <a:fillRect/>
+          </a:stretch>
+        </p:blipFill>
+        <p:spPr>
+          <a:xfrm>
+            <a:off x="7005571" y="1498925"/>
+            <a:ext cx="4107026" cy="3164430"/>
+          </a:xfrm>
+          <a:prstGeom prst="rect">
+            <a:avLst/>
+          </a:prstGeom>
+        </p:spPr>
+      </p:pic>
     </p:spTree>
     <p:extLst>
       <p:ext uri="{BB962C8B-B14F-4D97-AF65-F5344CB8AC3E}">
@@ -17074,6 +17240,654 @@
 </file>
 
 <file path=ppt/slides/slide25.xml><?xml version="1.0" encoding="utf-8"?>
+<p:sld xmlns:a="http://schemas.openxmlformats.org/drawingml/2006/main" xmlns:r="http://schemas.openxmlformats.org/officeDocument/2006/relationships" xmlns:p="http://schemas.openxmlformats.org/presentationml/2006/main">
+  <p:cSld>
+    <p:spTree>
+      <p:nvGrpSpPr>
+        <p:cNvPr id="1" name="">
+          <a:extLst>
+            <a:ext uri="{FF2B5EF4-FFF2-40B4-BE49-F238E27FC236}">
+              <a16:creationId xmlns:a16="http://schemas.microsoft.com/office/drawing/2014/main" id="{5472D1A9-CD98-8B8E-6121-7F6EC000F95B}"/>
+            </a:ext>
+          </a:extLst>
+        </p:cNvPr>
+        <p:cNvGrpSpPr/>
+        <p:nvPr/>
+      </p:nvGrpSpPr>
+      <p:grpSpPr>
+        <a:xfrm>
+          <a:off x="0" y="0"/>
+          <a:ext cx="0" cy="0"/>
+          <a:chOff x="0" y="0"/>
+          <a:chExt cx="0" cy="0"/>
+        </a:xfrm>
+      </p:grpSpPr>
+      <p:sp>
+        <p:nvSpPr>
+          <p:cNvPr id="16" name="object 16">
+            <a:extLst>
+              <a:ext uri="{FF2B5EF4-FFF2-40B4-BE49-F238E27FC236}">
+                <a16:creationId xmlns:a16="http://schemas.microsoft.com/office/drawing/2014/main" id="{07745D7B-7629-1578-718C-26F2AD549FEB}"/>
+              </a:ext>
+            </a:extLst>
+          </p:cNvPr>
+          <p:cNvSpPr txBox="1">
+            <a:spLocks noGrp="1"/>
+          </p:cNvSpPr>
+          <p:nvPr>
+            <p:ph type="title"/>
+          </p:nvPr>
+        </p:nvSpPr>
+        <p:spPr>
+          <a:xfrm>
+            <a:off x="685800" y="408883"/>
+            <a:ext cx="10994410" cy="1090042"/>
+          </a:xfrm>
+          <a:prstGeom prst="rect">
+            <a:avLst/>
+          </a:prstGeom>
+        </p:spPr>
+        <p:txBody>
+          <a:bodyPr vert="horz" wrap="square" lIns="0" tIns="12700" rIns="0" bIns="0" rtlCol="0">
+            <a:spAutoFit/>
+          </a:bodyPr>
+          <a:lstStyle/>
+          <a:p>
+            <a:pPr marL="12700">
+              <a:lnSpc>
+                <a:spcPct val="100000"/>
+              </a:lnSpc>
+              <a:spcBef>
+                <a:spcPts val="100"/>
+              </a:spcBef>
+            </a:pPr>
+            <a:r>
+              <a:rPr lang="en-US" sz="2500" dirty="0"/>
+              <a:t>Extra #1 – Directional coupler gap dependence</a:t>
+            </a:r>
+            <a:br>
+              <a:rPr lang="en-US" sz="2500" dirty="0"/>
+            </a:br>
+            <a:r>
+              <a:rPr lang="en-US" b="0" dirty="0"/>
+              <a:t>Wavelength 1.55 µm, width 1.0 µm, </a:t>
+            </a:r>
+            <a:r>
+              <a:rPr lang="en-US" dirty="0"/>
+              <a:t>gap 0.2-2.4 µm </a:t>
+            </a:r>
+            <a:r>
+              <a:rPr lang="en-US" b="0" dirty="0"/>
+              <a:t>(step 0.2 µm)</a:t>
+            </a:r>
+            <a:br>
+              <a:rPr lang="es-ES" sz="2500" spc="-5" dirty="0">
+                <a:latin typeface="+mj-lt"/>
+                <a:cs typeface="Lucida Sans"/>
+              </a:rPr>
+            </a:br>
+            <a:endParaRPr sz="2500" b="0" dirty="0">
+              <a:latin typeface="+mj-lt"/>
+              <a:cs typeface="Lucida Sans"/>
+            </a:endParaRPr>
+          </a:p>
+        </p:txBody>
+      </p:sp>
+      <p:pic>
+        <p:nvPicPr>
+          <p:cNvPr id="83" name="Gráfico 82">
+            <a:extLst>
+              <a:ext uri="{FF2B5EF4-FFF2-40B4-BE49-F238E27FC236}">
+                <a16:creationId xmlns:a16="http://schemas.microsoft.com/office/drawing/2014/main" id="{E206F50A-2EBF-E614-FA80-DC9DD4809F2B}"/>
+              </a:ext>
+            </a:extLst>
+          </p:cNvPr>
+          <p:cNvPicPr>
+            <a:picLocks noChangeAspect="1"/>
+          </p:cNvPicPr>
+          <p:nvPr/>
+        </p:nvPicPr>
+        <p:blipFill>
+          <a:blip>
+            <a:extLst>
+              <a:ext uri="{96DAC541-7B7A-43D3-8B79-37D633B846F1}">
+                <asvg:svgBlip xmlns:asvg="http://schemas.microsoft.com/office/drawing/2016/SVG/main" r:embed="rId3"/>
+              </a:ext>
+            </a:extLst>
+          </a:blip>
+          <a:stretch>
+            <a:fillRect/>
+          </a:stretch>
+        </p:blipFill>
+        <p:spPr>
+          <a:xfrm>
+            <a:off x="5045006" y="6356057"/>
+            <a:ext cx="6409575" cy="363174"/>
+          </a:xfrm>
+          <a:prstGeom prst="rect">
+            <a:avLst/>
+          </a:prstGeom>
+        </p:spPr>
+      </p:pic>
+      <p:sp>
+        <p:nvSpPr>
+          <p:cNvPr id="84" name="Marcador de número de diapositiva 83">
+            <a:extLst>
+              <a:ext uri="{FF2B5EF4-FFF2-40B4-BE49-F238E27FC236}">
+                <a16:creationId xmlns:a16="http://schemas.microsoft.com/office/drawing/2014/main" id="{9B52DFDD-C90B-8310-C025-E0ECE8C0B9E2}"/>
+              </a:ext>
+            </a:extLst>
+          </p:cNvPr>
+          <p:cNvSpPr>
+            <a:spLocks noGrp="1"/>
+          </p:cNvSpPr>
+          <p:nvPr>
+            <p:ph type="sldNum" sz="quarter" idx="7"/>
+          </p:nvPr>
+        </p:nvSpPr>
+        <p:spPr/>
+        <p:txBody>
+          <a:bodyPr/>
+          <a:lstStyle/>
+          <a:p>
+            <a:fld id="{B6F15528-21DE-4FAA-801E-634DDDAF4B2B}" type="slidenum">
+              <a:rPr lang="es-ES" smtClean="0"/>
+              <a:t>25</a:t>
+            </a:fld>
+            <a:endParaRPr lang="es-ES"/>
+          </a:p>
+        </p:txBody>
+      </p:sp>
+      <p:sp>
+        <p:nvSpPr>
+          <p:cNvPr id="3" name="Marcador de pie de página 2">
+            <a:extLst>
+              <a:ext uri="{FF2B5EF4-FFF2-40B4-BE49-F238E27FC236}">
+                <a16:creationId xmlns:a16="http://schemas.microsoft.com/office/drawing/2014/main" id="{6DC26FAC-847F-CF6D-E736-C19DBE61E213}"/>
+              </a:ext>
+            </a:extLst>
+          </p:cNvPr>
+          <p:cNvSpPr>
+            <a:spLocks noGrp="1"/>
+          </p:cNvSpPr>
+          <p:nvPr>
+            <p:ph type="ftr" sz="quarter" idx="5"/>
+          </p:nvPr>
+        </p:nvSpPr>
+        <p:spPr/>
+        <p:txBody>
+          <a:bodyPr/>
+          <a:lstStyle/>
+          <a:p>
+            <a:pPr marL="12700">
+              <a:spcBef>
+                <a:spcPts val="15"/>
+              </a:spcBef>
+            </a:pPr>
+            <a:r>
+              <a:rPr lang="es-ES" spc="-5"/>
+              <a:t>LAB 2.0. COUPLERS</a:t>
+            </a:r>
+            <a:endParaRPr lang="es-ES" spc="-5" dirty="0"/>
+          </a:p>
+        </p:txBody>
+      </p:sp>
+      <mc:AlternateContent xmlns:mc="http://schemas.openxmlformats.org/markup-compatibility/2006">
+        <mc:Choice xmlns:a14="http://schemas.microsoft.com/office/drawing/2010/main" Requires="a14">
+          <p:sp>
+            <p:nvSpPr>
+              <p:cNvPr id="2" name="CuadroTexto 1">
+                <a:extLst>
+                  <a:ext uri="{FF2B5EF4-FFF2-40B4-BE49-F238E27FC236}">
+                    <a16:creationId xmlns:a16="http://schemas.microsoft.com/office/drawing/2014/main" id="{79C670B6-5DD9-B08F-DDF1-A71B39764366}"/>
+                  </a:ext>
+                </a:extLst>
+              </p:cNvPr>
+              <p:cNvSpPr txBox="1"/>
+              <p:nvPr/>
+            </p:nvSpPr>
+            <p:spPr>
+              <a:xfrm>
+                <a:off x="496014" y="1447800"/>
+                <a:ext cx="11199971" cy="2646878"/>
+              </a:xfrm>
+              <a:prstGeom prst="rect">
+                <a:avLst/>
+              </a:prstGeom>
+              <a:solidFill>
+                <a:schemeClr val="bg1">
+                  <a:lumMod val="95000"/>
+                </a:schemeClr>
+              </a:solidFill>
+              <a:ln w="28575">
+                <a:solidFill>
+                  <a:srgbClr val="E0700D"/>
+                </a:solidFill>
+              </a:ln>
+            </p:spPr>
+            <p:txBody>
+              <a:bodyPr wrap="square" rtlCol="0">
+                <a:spAutoFit/>
+              </a:bodyPr>
+              <a:lstStyle/>
+              <a:p>
+                <a:pPr algn="just"/>
+                <a:r>
+                  <a:rPr lang="en-US" sz="1200" b="1" i="1" dirty="0">
+                    <a:latin typeface="Arial" panose="020B0604020202020204" pitchFamily="34" charset="0"/>
+                    <a:cs typeface="Arial" panose="020B0604020202020204" pitchFamily="34" charset="0"/>
+                  </a:rPr>
+                  <a:t>Make conclusions and observations from your results</a:t>
+                </a:r>
+              </a:p>
+              <a:p>
+                <a:pPr algn="just"/>
+                <a:endParaRPr lang="en-US" sz="1200" b="1" i="1" dirty="0">
+                  <a:latin typeface="Arial" panose="020B0604020202020204" pitchFamily="34" charset="0"/>
+                  <a:cs typeface="Arial" panose="020B0604020202020204" pitchFamily="34" charset="0"/>
+                </a:endParaRPr>
+              </a:p>
+              <a:p>
+                <a:pPr algn="just"/>
+                <a:r>
+                  <a:rPr lang="es-ES" sz="1000" dirty="0">
+                    <a:latin typeface="Arial" panose="020B0604020202020204" pitchFamily="34" charset="0"/>
+                    <a:cs typeface="Arial" panose="020B0604020202020204" pitchFamily="34" charset="0"/>
+                  </a:rPr>
+                  <a:t>En este ejercicio, se ha diseñado un acoplador direccional y se ha realizado un barrido de su gap, es decir, la distancia entre sus dos guías. Posteriormente, se ha simulado la longitud de acoplo </a:t>
+                </a:r>
+                <a14:m>
+                  <m:oMath xmlns:m="http://schemas.openxmlformats.org/officeDocument/2006/math">
+                    <m:sSub>
+                      <m:sSubPr>
+                        <m:ctrlPr>
+                          <a:rPr lang="ar-AE" sz="1000"/>
+                        </m:ctrlPr>
+                      </m:sSubPr>
+                      <m:e>
+                        <m:r>
+                          <m:rPr>
+                            <m:sty m:val="p"/>
+                          </m:rPr>
+                          <a:rPr lang="ar-AE" sz="1000" b="0" i="0"/>
+                          <m:t>L</m:t>
+                        </m:r>
+                      </m:e>
+                      <m:sub>
+                        <m:r>
+                          <m:rPr>
+                            <m:sty m:val="p"/>
+                          </m:rPr>
+                          <a:rPr lang="ar-AE" sz="1000" b="0" i="0"/>
+                          <m:t>π</m:t>
+                        </m:r>
+                        <m:r>
+                          <a:rPr lang="es-ES" sz="1000" b="0" i="0" smtClean="0">
+                            <a:latin typeface="Cambria Math" panose="02040503050406030204" pitchFamily="18" charset="0"/>
+                          </a:rPr>
+                          <m:t> </m:t>
+                        </m:r>
+                      </m:sub>
+                    </m:sSub>
+                  </m:oMath>
+                </a14:m>
+                <a:r>
+                  <a:rPr lang="es-ES" sz="1000" dirty="0">
+                    <a:latin typeface="Arial" panose="020B0604020202020204" pitchFamily="34" charset="0"/>
+                    <a:cs typeface="Arial" panose="020B0604020202020204" pitchFamily="34" charset="0"/>
+                  </a:rPr>
+                  <a:t>en función de dicho gap.</a:t>
+                </a:r>
+              </a:p>
+              <a:p>
+                <a:pPr algn="just"/>
+                <a:endParaRPr lang="es-ES" sz="1000" dirty="0">
+                  <a:latin typeface="Arial" panose="020B0604020202020204" pitchFamily="34" charset="0"/>
+                  <a:cs typeface="Arial" panose="020B0604020202020204" pitchFamily="34" charset="0"/>
+                </a:endParaRPr>
+              </a:p>
+              <a:p>
+                <a:pPr algn="just"/>
+                <a:r>
+                  <a:rPr lang="es-ES" sz="1000" dirty="0">
+                    <a:latin typeface="Arial" panose="020B0604020202020204" pitchFamily="34" charset="0"/>
+                    <a:cs typeface="Arial" panose="020B0604020202020204" pitchFamily="34" charset="0"/>
+                  </a:rPr>
+                  <a:t>Se observa que al aumentar el gap, </a:t>
+                </a:r>
+                <a14:m>
+                  <m:oMath xmlns:m="http://schemas.openxmlformats.org/officeDocument/2006/math">
+                    <m:sSub>
+                      <m:sSubPr>
+                        <m:ctrlPr>
+                          <a:rPr lang="ar-AE" sz="1000"/>
+                        </m:ctrlPr>
+                      </m:sSubPr>
+                      <m:e>
+                        <m:r>
+                          <m:rPr>
+                            <m:sty m:val="p"/>
+                          </m:rPr>
+                          <a:rPr lang="ar-AE" sz="1000" b="0" i="0"/>
+                          <m:t>L</m:t>
+                        </m:r>
+                      </m:e>
+                      <m:sub>
+                        <m:r>
+                          <m:rPr>
+                            <m:sty m:val="p"/>
+                          </m:rPr>
+                          <a:rPr lang="ar-AE" sz="1000" b="0" i="0"/>
+                          <m:t>π</m:t>
+                        </m:r>
+                      </m:sub>
+                    </m:sSub>
+                  </m:oMath>
+                </a14:m>
+                <a:r>
+                  <a:rPr lang="es-ES" sz="1000" dirty="0">
+                    <a:latin typeface="Arial" panose="020B0604020202020204" pitchFamily="34" charset="0"/>
+                    <a:cs typeface="Arial" panose="020B0604020202020204" pitchFamily="34" charset="0"/>
+                  </a:rPr>
+                  <a:t> aumenta significativamente porque al separar más las guías, el solapamiento de los campos evanescentes disminuye, al igual que la diferencia entre los índices efectivos, reduciendo el acoplo entre ellas.</a:t>
+                </a:r>
+              </a:p>
+              <a:p>
+                <a:pPr algn="just"/>
+                <a:r>
+                  <a:rPr lang="es-ES" sz="1000" dirty="0">
+                    <a:latin typeface="Arial" panose="020B0604020202020204" pitchFamily="34" charset="0"/>
+                    <a:cs typeface="Arial" panose="020B0604020202020204" pitchFamily="34" charset="0"/>
+                  </a:rPr>
+                  <a:t>Como consecuencia, la transferencia de potencia entre las guías es más lenta, por lo que se necesita una mayor longitud de propagación para completar el acoplo. Por tanto, al aumentar el gap, el acoplo disminuye y la longitud de acoplo </a:t>
+                </a:r>
+                <a14:m>
+                  <m:oMath xmlns:m="http://schemas.openxmlformats.org/officeDocument/2006/math">
+                    <m:sSub>
+                      <m:sSubPr>
+                        <m:ctrlPr>
+                          <a:rPr lang="ar-AE" sz="1000"/>
+                        </m:ctrlPr>
+                      </m:sSubPr>
+                      <m:e>
+                        <m:r>
+                          <m:rPr>
+                            <m:sty m:val="p"/>
+                          </m:rPr>
+                          <a:rPr lang="ar-AE" sz="1000" b="0" i="0"/>
+                          <m:t>L</m:t>
+                        </m:r>
+                      </m:e>
+                      <m:sub>
+                        <m:r>
+                          <m:rPr>
+                            <m:sty m:val="p"/>
+                          </m:rPr>
+                          <a:rPr lang="ar-AE" sz="1000" b="0" i="0"/>
+                          <m:t>π</m:t>
+                        </m:r>
+                      </m:sub>
+                    </m:sSub>
+                  </m:oMath>
+                </a14:m>
+                <a:r>
+                  <a:rPr lang="es-ES" sz="1000" dirty="0">
+                    <a:latin typeface="Arial" panose="020B0604020202020204" pitchFamily="34" charset="0"/>
+                    <a:cs typeface="Arial" panose="020B0604020202020204" pitchFamily="34" charset="0"/>
+                  </a:rPr>
+                  <a:t> aumenta.</a:t>
+                </a:r>
+                <a:endParaRPr lang="ar-AE" sz="1000" dirty="0">
+                  <a:latin typeface="Arial" panose="020B0604020202020204" pitchFamily="34" charset="0"/>
+                  <a:cs typeface="Arial" panose="020B0604020202020204" pitchFamily="34" charset="0"/>
+                </a:endParaRPr>
+              </a:p>
+              <a:p>
+                <a:pPr algn="just"/>
+                <a:endParaRPr lang="en-US" sz="1000" dirty="0">
+                  <a:latin typeface="Arial" panose="020B0604020202020204" pitchFamily="34" charset="0"/>
+                  <a:cs typeface="Arial" panose="020B0604020202020204" pitchFamily="34" charset="0"/>
+                </a:endParaRPr>
+              </a:p>
+              <a:p>
+                <a:pPr algn="just"/>
+                <a:r>
+                  <a:rPr lang="es-ES" sz="1000" dirty="0">
+                    <a:latin typeface="Arial" panose="020B0604020202020204" pitchFamily="34" charset="0"/>
+                    <a:cs typeface="Arial" panose="020B0604020202020204" pitchFamily="34" charset="0"/>
+                  </a:rPr>
+                  <a:t>Además, tal y como se ve en las gráficas este aumento no es lineal, sino que presenta un crecimiento aproximadamente exponencial, debido a la naturaleza exponencial de la disminución de los campos evanescentes.</a:t>
+                </a:r>
+              </a:p>
+              <a:p>
+                <a:pPr algn="just"/>
+                <a:endParaRPr lang="es-ES" sz="1000" dirty="0">
+                  <a:latin typeface="Arial" panose="020B0604020202020204" pitchFamily="34" charset="0"/>
+                  <a:cs typeface="Arial" panose="020B0604020202020204" pitchFamily="34" charset="0"/>
+                </a:endParaRPr>
+              </a:p>
+              <a:p>
+                <a:pPr algn="just"/>
+                <a:r>
+                  <a:rPr lang="es-ES" sz="1000" dirty="0">
+                    <a:latin typeface="Arial" panose="020B0604020202020204" pitchFamily="34" charset="0"/>
+                    <a:cs typeface="Arial" panose="020B0604020202020204" pitchFamily="34" charset="0"/>
+                  </a:rPr>
+                  <a:t>Por último, comparando los casos </a:t>
+                </a:r>
+                <a:r>
+                  <a:rPr lang="es-ES" sz="1000" dirty="0" err="1">
+                    <a:latin typeface="Arial" panose="020B0604020202020204" pitchFamily="34" charset="0"/>
+                    <a:cs typeface="Arial" panose="020B0604020202020204" pitchFamily="34" charset="0"/>
+                  </a:rPr>
+                  <a:t>deep</a:t>
+                </a:r>
+                <a:r>
+                  <a:rPr lang="es-ES" sz="1000" dirty="0">
+                    <a:latin typeface="Arial" panose="020B0604020202020204" pitchFamily="34" charset="0"/>
+                    <a:cs typeface="Arial" panose="020B0604020202020204" pitchFamily="34" charset="0"/>
+                  </a:rPr>
+                  <a:t> y </a:t>
+                </a:r>
+                <a:r>
+                  <a:rPr lang="es-ES" sz="1000" dirty="0" err="1">
+                    <a:latin typeface="Arial" panose="020B0604020202020204" pitchFamily="34" charset="0"/>
+                    <a:cs typeface="Arial" panose="020B0604020202020204" pitchFamily="34" charset="0"/>
+                  </a:rPr>
+                  <a:t>shallow</a:t>
+                </a:r>
+                <a:r>
+                  <a:rPr lang="es-ES" sz="1000" dirty="0">
+                    <a:latin typeface="Arial" panose="020B0604020202020204" pitchFamily="34" charset="0"/>
+                    <a:cs typeface="Arial" panose="020B0604020202020204" pitchFamily="34" charset="0"/>
+                  </a:rPr>
+                  <a:t>, se observa que el acoplo es mayor en el caso </a:t>
+                </a:r>
+                <a:r>
+                  <a:rPr lang="es-ES" sz="1000" dirty="0" err="1">
+                    <a:latin typeface="Arial" panose="020B0604020202020204" pitchFamily="34" charset="0"/>
+                    <a:cs typeface="Arial" panose="020B0604020202020204" pitchFamily="34" charset="0"/>
+                  </a:rPr>
+                  <a:t>shallow</a:t>
+                </a:r>
+                <a:r>
+                  <a:rPr lang="es-ES" sz="1000" dirty="0">
+                    <a:latin typeface="Arial" panose="020B0604020202020204" pitchFamily="34" charset="0"/>
+                    <a:cs typeface="Arial" panose="020B0604020202020204" pitchFamily="34" charset="0"/>
+                  </a:rPr>
+                  <a:t>: presenta menor </a:t>
+                </a:r>
+                <a14:m>
+                  <m:oMath xmlns:m="http://schemas.openxmlformats.org/officeDocument/2006/math">
+                    <m:sSub>
+                      <m:sSubPr>
+                        <m:ctrlPr>
+                          <a:rPr lang="ar-AE" sz="1000"/>
+                        </m:ctrlPr>
+                      </m:sSubPr>
+                      <m:e>
+                        <m:r>
+                          <m:rPr>
+                            <m:sty m:val="p"/>
+                          </m:rPr>
+                          <a:rPr lang="ar-AE" sz="1000" b="0" i="0"/>
+                          <m:t>L</m:t>
+                        </m:r>
+                      </m:e>
+                      <m:sub>
+                        <m:r>
+                          <m:rPr>
+                            <m:sty m:val="p"/>
+                          </m:rPr>
+                          <a:rPr lang="ar-AE" sz="1000" b="0" i="0"/>
+                          <m:t>π</m:t>
+                        </m:r>
+                      </m:sub>
+                    </m:sSub>
+                    <m:r>
+                      <a:rPr lang="es-ES" sz="1000" b="0" i="0" smtClean="0">
+                        <a:latin typeface="Cambria Math" panose="02040503050406030204" pitchFamily="18" charset="0"/>
+                      </a:rPr>
+                      <m:t>, </m:t>
+                    </m:r>
+                  </m:oMath>
+                </a14:m>
+                <a:r>
+                  <a:rPr lang="es-ES" sz="1000" dirty="0">
+                    <a:latin typeface="Arial" panose="020B0604020202020204" pitchFamily="34" charset="0"/>
+                    <a:cs typeface="Arial" panose="020B0604020202020204" pitchFamily="34" charset="0"/>
+                  </a:rPr>
+                  <a:t>ya que el campo se extiende más fuera del núcleo por la menor confinación, aumentando el solapamiento entre las guías. En cambio, en el caso </a:t>
+                </a:r>
+                <a:r>
+                  <a:rPr lang="es-ES" sz="1000" dirty="0" err="1">
+                    <a:latin typeface="Arial" panose="020B0604020202020204" pitchFamily="34" charset="0"/>
+                    <a:cs typeface="Arial" panose="020B0604020202020204" pitchFamily="34" charset="0"/>
+                  </a:rPr>
+                  <a:t>deep</a:t>
+                </a:r>
+                <a:r>
+                  <a:rPr lang="es-ES" sz="1000" dirty="0">
+                    <a:latin typeface="Arial" panose="020B0604020202020204" pitchFamily="34" charset="0"/>
+                    <a:cs typeface="Arial" panose="020B0604020202020204" pitchFamily="34" charset="0"/>
+                  </a:rPr>
+                  <a:t> el confinamiento es mayor y el acoplo es más débil, dando lugar a valores de </a:t>
+                </a:r>
+                <a14:m>
+                  <m:oMath xmlns:m="http://schemas.openxmlformats.org/officeDocument/2006/math">
+                    <m:sSub>
+                      <m:sSubPr>
+                        <m:ctrlPr>
+                          <a:rPr lang="ar-AE" sz="1000"/>
+                        </m:ctrlPr>
+                      </m:sSubPr>
+                      <m:e>
+                        <m:r>
+                          <m:rPr>
+                            <m:sty m:val="p"/>
+                          </m:rPr>
+                          <a:rPr lang="ar-AE" sz="1000" b="0" i="0"/>
+                          <m:t>L</m:t>
+                        </m:r>
+                      </m:e>
+                      <m:sub>
+                        <m:r>
+                          <m:rPr>
+                            <m:sty m:val="p"/>
+                          </m:rPr>
+                          <a:rPr lang="ar-AE" sz="1000" b="0" i="0"/>
+                          <m:t>π</m:t>
+                        </m:r>
+                      </m:sub>
+                    </m:sSub>
+                  </m:oMath>
+                </a14:m>
+                <a:r>
+                  <a:rPr lang="es-ES" sz="1000" dirty="0">
+                    <a:latin typeface="Arial" panose="020B0604020202020204" pitchFamily="34" charset="0"/>
+                    <a:cs typeface="Arial" panose="020B0604020202020204" pitchFamily="34" charset="0"/>
+                  </a:rPr>
+                  <a:t>más altos.</a:t>
+                </a:r>
+                <a:endParaRPr lang="en-US" sz="1200" dirty="0">
+                  <a:latin typeface="Arial" panose="020B0604020202020204" pitchFamily="34" charset="0"/>
+                  <a:cs typeface="Arial" panose="020B0604020202020204" pitchFamily="34" charset="0"/>
+                </a:endParaRPr>
+              </a:p>
+              <a:p>
+                <a:pPr algn="just"/>
+                <a:endParaRPr lang="en-US" sz="1200" dirty="0">
+                  <a:latin typeface="Arial" panose="020B0604020202020204" pitchFamily="34" charset="0"/>
+                  <a:cs typeface="Arial" panose="020B0604020202020204" pitchFamily="34" charset="0"/>
+                </a:endParaRPr>
+              </a:p>
+            </p:txBody>
+          </p:sp>
+        </mc:Choice>
+        <mc:Fallback>
+          <p:sp>
+            <p:nvSpPr>
+              <p:cNvPr id="2" name="CuadroTexto 1">
+                <a:extLst>
+                  <a:ext uri="{FF2B5EF4-FFF2-40B4-BE49-F238E27FC236}">
+                    <a16:creationId xmlns:a16="http://schemas.microsoft.com/office/drawing/2014/main" id="{79C670B6-5DD9-B08F-DDF1-A71B39764366}"/>
+                  </a:ext>
+                </a:extLst>
+              </p:cNvPr>
+              <p:cNvSpPr txBox="1">
+                <a:spLocks noRot="1" noChangeAspect="1" noMove="1" noResize="1" noEditPoints="1" noAdjustHandles="1" noChangeArrowheads="1" noChangeShapeType="1" noTextEdit="1"/>
+              </p:cNvSpPr>
+              <p:nvPr/>
+            </p:nvSpPr>
+            <p:spPr>
+              <a:xfrm>
+                <a:off x="496014" y="1447800"/>
+                <a:ext cx="11199971" cy="2646878"/>
+              </a:xfrm>
+              <a:prstGeom prst="rect">
+                <a:avLst/>
+              </a:prstGeom>
+              <a:blipFill>
+                <a:blip r:embed="rId4"/>
+                <a:stretch>
+                  <a:fillRect/>
+                </a:stretch>
+              </a:blipFill>
+              <a:ln w="28575">
+                <a:solidFill>
+                  <a:srgbClr val="E0700D"/>
+                </a:solidFill>
+              </a:ln>
+            </p:spPr>
+            <p:txBody>
+              <a:bodyPr/>
+              <a:lstStyle/>
+              <a:p>
+                <a:r>
+                  <a:rPr lang="es-ES">
+                    <a:noFill/>
+                  </a:rPr>
+                  <a:t> </a:t>
+                </a:r>
+              </a:p>
+            </p:txBody>
+          </p:sp>
+        </mc:Fallback>
+      </mc:AlternateContent>
+    </p:spTree>
+    <p:extLst>
+      <p:ext uri="{BB962C8B-B14F-4D97-AF65-F5344CB8AC3E}">
+        <p14:creationId xmlns:p14="http://schemas.microsoft.com/office/powerpoint/2010/main" val="2452912536"/>
+      </p:ext>
+    </p:extLst>
+  </p:cSld>
+  <p:clrMapOvr>
+    <a:masterClrMapping/>
+  </p:clrMapOvr>
+</p:sld>
+</file>
+
+<file path=ppt/slides/slide26.xml><?xml version="1.0" encoding="utf-8"?>
 <p:sld xmlns:a="http://schemas.openxmlformats.org/drawingml/2006/main" xmlns:r="http://schemas.openxmlformats.org/officeDocument/2006/relationships" xmlns:p="http://schemas.openxmlformats.org/presentationml/2006/main">
   <p:cSld>
     <p:spTree>
@@ -17229,7 +18043,7 @@
           <a:p>
             <a:fld id="{B6F15528-21DE-4FAA-801E-634DDDAF4B2B}" type="slidenum">
               <a:rPr lang="es-ES" smtClean="0"/>
-              <a:t>25</a:t>
+              <a:t>26</a:t>
             </a:fld>
             <a:endParaRPr lang="es-ES"/>
           </a:p>
@@ -17266,89 +18080,6 @@
               <a:t>LAB 2.0. COUPLERS</a:t>
             </a:r>
             <a:endParaRPr lang="es-ES" spc="-5" dirty="0"/>
-          </a:p>
-        </p:txBody>
-      </p:sp>
-      <p:sp>
-        <p:nvSpPr>
-          <p:cNvPr id="2" name="CuadroTexto 1">
-            <a:extLst>
-              <a:ext uri="{FF2B5EF4-FFF2-40B4-BE49-F238E27FC236}">
-                <a16:creationId xmlns:a16="http://schemas.microsoft.com/office/drawing/2014/main" id="{181326FD-308E-2C47-D5D2-57B3357241AA}"/>
-              </a:ext>
-            </a:extLst>
-          </p:cNvPr>
-          <p:cNvSpPr txBox="1"/>
-          <p:nvPr/>
-        </p:nvSpPr>
-        <p:spPr>
-          <a:xfrm>
-            <a:off x="609441" y="4860334"/>
-            <a:ext cx="11199971" cy="1200329"/>
-          </a:xfrm>
-          <a:prstGeom prst="rect">
-            <a:avLst/>
-          </a:prstGeom>
-          <a:solidFill>
-            <a:schemeClr val="bg1">
-              <a:lumMod val="95000"/>
-            </a:schemeClr>
-          </a:solidFill>
-          <a:ln w="28575">
-            <a:solidFill>
-              <a:srgbClr val="E0700D"/>
-            </a:solidFill>
-          </a:ln>
-        </p:spPr>
-        <p:txBody>
-          <a:bodyPr wrap="square" rtlCol="0">
-            <a:spAutoFit/>
-          </a:bodyPr>
-          <a:lstStyle/>
-          <a:p>
-            <a:pPr algn="just"/>
-            <a:r>
-              <a:rPr lang="en-US" sz="1200" dirty="0">
-                <a:latin typeface="Arial" panose="020B0604020202020204" pitchFamily="34" charset="0"/>
-                <a:cs typeface="Arial" panose="020B0604020202020204" pitchFamily="34" charset="0"/>
-              </a:rPr>
-              <a:t>Comment results</a:t>
-            </a:r>
-          </a:p>
-          <a:p>
-            <a:pPr algn="just"/>
-            <a:endParaRPr lang="en-US" sz="1200" dirty="0">
-              <a:latin typeface="Arial" panose="020B0604020202020204" pitchFamily="34" charset="0"/>
-              <a:cs typeface="Arial" panose="020B0604020202020204" pitchFamily="34" charset="0"/>
-            </a:endParaRPr>
-          </a:p>
-          <a:p>
-            <a:pPr algn="just"/>
-            <a:endParaRPr lang="en-US" sz="1200" dirty="0">
-              <a:latin typeface="Arial" panose="020B0604020202020204" pitchFamily="34" charset="0"/>
-              <a:cs typeface="Arial" panose="020B0604020202020204" pitchFamily="34" charset="0"/>
-            </a:endParaRPr>
-          </a:p>
-          <a:p>
-            <a:pPr algn="just"/>
-            <a:endParaRPr lang="en-US" sz="1200" dirty="0">
-              <a:latin typeface="Arial" panose="020B0604020202020204" pitchFamily="34" charset="0"/>
-              <a:cs typeface="Arial" panose="020B0604020202020204" pitchFamily="34" charset="0"/>
-            </a:endParaRPr>
-          </a:p>
-          <a:p>
-            <a:pPr algn="just"/>
-            <a:endParaRPr lang="en-US" sz="1200" dirty="0">
-              <a:latin typeface="Arial" panose="020B0604020202020204" pitchFamily="34" charset="0"/>
-              <a:cs typeface="Arial" panose="020B0604020202020204" pitchFamily="34" charset="0"/>
-            </a:endParaRPr>
-          </a:p>
-          <a:p>
-            <a:pPr algn="just"/>
-            <a:endParaRPr lang="en-US" sz="1200" dirty="0">
-              <a:latin typeface="Arial" panose="020B0604020202020204" pitchFamily="34" charset="0"/>
-              <a:cs typeface="Arial" panose="020B0604020202020204" pitchFamily="34" charset="0"/>
-            </a:endParaRPr>
           </a:p>
         </p:txBody>
       </p:sp>
@@ -17456,42 +18187,6 @@
           </a:p>
         </p:txBody>
       </p:sp>
-      <p:sp>
-        <p:nvSpPr>
-          <p:cNvPr id="7" name="CuadroTexto 6">
-            <a:extLst>
-              <a:ext uri="{FF2B5EF4-FFF2-40B4-BE49-F238E27FC236}">
-                <a16:creationId xmlns:a16="http://schemas.microsoft.com/office/drawing/2014/main" id="{5F16E403-DF61-C9A0-D57F-2E61BEFA8887}"/>
-              </a:ext>
-            </a:extLst>
-          </p:cNvPr>
-          <p:cNvSpPr txBox="1"/>
-          <p:nvPr/>
-        </p:nvSpPr>
-        <p:spPr>
-          <a:xfrm>
-            <a:off x="6331152" y="4342178"/>
-            <a:ext cx="2269787" cy="369332"/>
-          </a:xfrm>
-          <a:prstGeom prst="rect">
-            <a:avLst/>
-          </a:prstGeom>
-          <a:noFill/>
-        </p:spPr>
-        <p:txBody>
-          <a:bodyPr wrap="square">
-            <a:spAutoFit/>
-          </a:bodyPr>
-          <a:lstStyle/>
-          <a:p>
-            <a:r>
-              <a:rPr lang="en-US" dirty="0"/>
-              <a:t>slab = 150nm</a:t>
-            </a:r>
-            <a:endParaRPr lang="es-ES" dirty="0"/>
-          </a:p>
-        </p:txBody>
-      </p:sp>
       <mc:AlternateContent xmlns:mc="http://schemas.openxmlformats.org/markup-compatibility/2006" xmlns:a14="http://schemas.microsoft.com/office/drawing/2010/main">
         <mc:Choice Requires="a14">
           <p:sp>
@@ -17772,6 +18467,66 @@
           </p:sp>
         </mc:Fallback>
       </mc:AlternateContent>
+      <p:pic>
+        <p:nvPicPr>
+          <p:cNvPr id="10" name="Imagen 9">
+            <a:extLst>
+              <a:ext uri="{FF2B5EF4-FFF2-40B4-BE49-F238E27FC236}">
+                <a16:creationId xmlns:a16="http://schemas.microsoft.com/office/drawing/2014/main" id="{685AEF6D-BFCD-F741-9C2F-23439D1A2085}"/>
+              </a:ext>
+            </a:extLst>
+          </p:cNvPr>
+          <p:cNvPicPr>
+            <a:picLocks noChangeAspect="1"/>
+          </p:cNvPicPr>
+          <p:nvPr/>
+        </p:nvPicPr>
+        <p:blipFill>
+          <a:blip r:embed="rId7"/>
+          <a:stretch>
+            <a:fillRect/>
+          </a:stretch>
+        </p:blipFill>
+        <p:spPr>
+          <a:xfrm>
+            <a:off x="931928" y="1637752"/>
+            <a:ext cx="5022796" cy="2926124"/>
+          </a:xfrm>
+          <a:prstGeom prst="rect">
+            <a:avLst/>
+          </a:prstGeom>
+        </p:spPr>
+      </p:pic>
+      <p:pic>
+        <p:nvPicPr>
+          <p:cNvPr id="12" name="Imagen 11">
+            <a:extLst>
+              <a:ext uri="{FF2B5EF4-FFF2-40B4-BE49-F238E27FC236}">
+                <a16:creationId xmlns:a16="http://schemas.microsoft.com/office/drawing/2014/main" id="{463FC4BF-F685-8F53-9E64-29BC9C63FFCC}"/>
+              </a:ext>
+            </a:extLst>
+          </p:cNvPr>
+          <p:cNvPicPr>
+            <a:picLocks noChangeAspect="1"/>
+          </p:cNvPicPr>
+          <p:nvPr/>
+        </p:nvPicPr>
+        <p:blipFill>
+          <a:blip r:embed="rId8"/>
+          <a:stretch>
+            <a:fillRect/>
+          </a:stretch>
+        </p:blipFill>
+        <p:spPr>
+          <a:xfrm>
+            <a:off x="6466714" y="1612870"/>
+            <a:ext cx="5195977" cy="3024524"/>
+          </a:xfrm>
+          <a:prstGeom prst="rect">
+            <a:avLst/>
+          </a:prstGeom>
+        </p:spPr>
+      </p:pic>
     </p:spTree>
     <p:extLst>
       <p:ext uri="{BB962C8B-B14F-4D97-AF65-F5344CB8AC3E}">
@@ -17785,7 +18540,677 @@
 </p:sld>
 </file>
 
-<file path=ppt/slides/slide26.xml><?xml version="1.0" encoding="utf-8"?>
+<file path=ppt/slides/slide27.xml><?xml version="1.0" encoding="utf-8"?>
+<p:sld xmlns:a="http://schemas.openxmlformats.org/drawingml/2006/main" xmlns:r="http://schemas.openxmlformats.org/officeDocument/2006/relationships" xmlns:p="http://schemas.openxmlformats.org/presentationml/2006/main">
+  <p:cSld>
+    <p:spTree>
+      <p:nvGrpSpPr>
+        <p:cNvPr id="1" name="">
+          <a:extLst>
+            <a:ext uri="{FF2B5EF4-FFF2-40B4-BE49-F238E27FC236}">
+              <a16:creationId xmlns:a16="http://schemas.microsoft.com/office/drawing/2014/main" id="{A916521D-8936-E7A3-655B-652E55EBA301}"/>
+            </a:ext>
+          </a:extLst>
+        </p:cNvPr>
+        <p:cNvGrpSpPr/>
+        <p:nvPr/>
+      </p:nvGrpSpPr>
+      <p:grpSpPr>
+        <a:xfrm>
+          <a:off x="0" y="0"/>
+          <a:ext cx="0" cy="0"/>
+          <a:chOff x="0" y="0"/>
+          <a:chExt cx="0" cy="0"/>
+        </a:xfrm>
+      </p:grpSpPr>
+      <p:sp>
+        <p:nvSpPr>
+          <p:cNvPr id="16" name="object 16">
+            <a:extLst>
+              <a:ext uri="{FF2B5EF4-FFF2-40B4-BE49-F238E27FC236}">
+                <a16:creationId xmlns:a16="http://schemas.microsoft.com/office/drawing/2014/main" id="{906D48DC-8D36-C44C-67D5-BFEF6524C62E}"/>
+              </a:ext>
+            </a:extLst>
+          </p:cNvPr>
+          <p:cNvSpPr txBox="1">
+            <a:spLocks noGrp="1"/>
+          </p:cNvSpPr>
+          <p:nvPr>
+            <p:ph type="title"/>
+          </p:nvPr>
+        </p:nvSpPr>
+        <p:spPr>
+          <a:xfrm>
+            <a:off x="685800" y="408883"/>
+            <a:ext cx="10994410" cy="1474763"/>
+          </a:xfrm>
+          <a:prstGeom prst="rect">
+            <a:avLst/>
+          </a:prstGeom>
+        </p:spPr>
+        <p:txBody>
+          <a:bodyPr vert="horz" wrap="square" lIns="0" tIns="12700" rIns="0" bIns="0" rtlCol="0">
+            <a:spAutoFit/>
+          </a:bodyPr>
+          <a:lstStyle/>
+          <a:p>
+            <a:pPr marL="12700">
+              <a:lnSpc>
+                <a:spcPct val="100000"/>
+              </a:lnSpc>
+              <a:spcBef>
+                <a:spcPts val="100"/>
+              </a:spcBef>
+            </a:pPr>
+            <a:r>
+              <a:rPr lang="en-US" sz="2500" dirty="0"/>
+              <a:t>Extra #2 – Directional wavelength dependence</a:t>
+            </a:r>
+            <a:br>
+              <a:rPr lang="en-US" sz="2500" dirty="0"/>
+            </a:br>
+            <a:r>
+              <a:rPr lang="en-US" b="0" dirty="0"/>
+              <a:t>Wavelengths </a:t>
+            </a:r>
+            <a:r>
+              <a:rPr lang="en-US" dirty="0"/>
+              <a:t>from 1.5 to 1.7 µm</a:t>
+            </a:r>
+            <a:r>
+              <a:rPr lang="en-US" b="0" dirty="0"/>
+              <a:t>, gap = 0.6 µm, width 1.0 µm</a:t>
+            </a:r>
+            <a:br>
+              <a:rPr lang="en-US" b="0" dirty="0"/>
+            </a:br>
+            <a:br>
+              <a:rPr lang="es-ES" sz="2500" spc="-5" dirty="0">
+                <a:latin typeface="+mj-lt"/>
+                <a:cs typeface="Lucida Sans"/>
+              </a:rPr>
+            </a:br>
+            <a:endParaRPr sz="2500" b="0" dirty="0">
+              <a:latin typeface="+mj-lt"/>
+              <a:cs typeface="Lucida Sans"/>
+            </a:endParaRPr>
+          </a:p>
+        </p:txBody>
+      </p:sp>
+      <p:pic>
+        <p:nvPicPr>
+          <p:cNvPr id="83" name="Gráfico 82">
+            <a:extLst>
+              <a:ext uri="{FF2B5EF4-FFF2-40B4-BE49-F238E27FC236}">
+                <a16:creationId xmlns:a16="http://schemas.microsoft.com/office/drawing/2014/main" id="{4E295E5C-0B9E-4B28-7F9C-9CE69CE62560}"/>
+              </a:ext>
+            </a:extLst>
+          </p:cNvPr>
+          <p:cNvPicPr>
+            <a:picLocks noChangeAspect="1"/>
+          </p:cNvPicPr>
+          <p:nvPr/>
+        </p:nvPicPr>
+        <p:blipFill>
+          <a:blip>
+            <a:extLst>
+              <a:ext uri="{96DAC541-7B7A-43D3-8B79-37D633B846F1}">
+                <asvg:svgBlip xmlns:asvg="http://schemas.microsoft.com/office/drawing/2016/SVG/main" r:embed="rId3"/>
+              </a:ext>
+            </a:extLst>
+          </a:blip>
+          <a:stretch>
+            <a:fillRect/>
+          </a:stretch>
+        </p:blipFill>
+        <p:spPr>
+          <a:xfrm>
+            <a:off x="5045006" y="6356057"/>
+            <a:ext cx="6409575" cy="363174"/>
+          </a:xfrm>
+          <a:prstGeom prst="rect">
+            <a:avLst/>
+          </a:prstGeom>
+        </p:spPr>
+      </p:pic>
+      <p:sp>
+        <p:nvSpPr>
+          <p:cNvPr id="84" name="Marcador de número de diapositiva 83">
+            <a:extLst>
+              <a:ext uri="{FF2B5EF4-FFF2-40B4-BE49-F238E27FC236}">
+                <a16:creationId xmlns:a16="http://schemas.microsoft.com/office/drawing/2014/main" id="{4A1A4E98-EBBD-C1CF-7FDF-3AA0AC7B09F8}"/>
+              </a:ext>
+            </a:extLst>
+          </p:cNvPr>
+          <p:cNvSpPr>
+            <a:spLocks noGrp="1"/>
+          </p:cNvSpPr>
+          <p:nvPr>
+            <p:ph type="sldNum" sz="quarter" idx="7"/>
+          </p:nvPr>
+        </p:nvSpPr>
+        <p:spPr/>
+        <p:txBody>
+          <a:bodyPr/>
+          <a:lstStyle/>
+          <a:p>
+            <a:fld id="{B6F15528-21DE-4FAA-801E-634DDDAF4B2B}" type="slidenum">
+              <a:rPr lang="es-ES" smtClean="0"/>
+              <a:t>27</a:t>
+            </a:fld>
+            <a:endParaRPr lang="es-ES"/>
+          </a:p>
+        </p:txBody>
+      </p:sp>
+      <p:sp>
+        <p:nvSpPr>
+          <p:cNvPr id="3" name="Marcador de pie de página 2">
+            <a:extLst>
+              <a:ext uri="{FF2B5EF4-FFF2-40B4-BE49-F238E27FC236}">
+                <a16:creationId xmlns:a16="http://schemas.microsoft.com/office/drawing/2014/main" id="{95B93DC7-CE29-91CD-1114-DE7A04C91D19}"/>
+              </a:ext>
+            </a:extLst>
+          </p:cNvPr>
+          <p:cNvSpPr>
+            <a:spLocks noGrp="1"/>
+          </p:cNvSpPr>
+          <p:nvPr>
+            <p:ph type="ftr" sz="quarter" idx="5"/>
+          </p:nvPr>
+        </p:nvSpPr>
+        <p:spPr/>
+        <p:txBody>
+          <a:bodyPr/>
+          <a:lstStyle/>
+          <a:p>
+            <a:pPr marL="12700">
+              <a:spcBef>
+                <a:spcPts val="15"/>
+              </a:spcBef>
+            </a:pPr>
+            <a:r>
+              <a:rPr lang="es-ES" spc="-5"/>
+              <a:t>LAB 2.0. COUPLERS</a:t>
+            </a:r>
+            <a:endParaRPr lang="es-ES" spc="-5" dirty="0"/>
+          </a:p>
+        </p:txBody>
+      </p:sp>
+      <mc:AlternateContent xmlns:mc="http://schemas.openxmlformats.org/markup-compatibility/2006">
+        <mc:Choice xmlns:a14="http://schemas.microsoft.com/office/drawing/2010/main" Requires="a14">
+          <p:sp>
+            <p:nvSpPr>
+              <p:cNvPr id="2" name="CuadroTexto 1">
+                <a:extLst>
+                  <a:ext uri="{FF2B5EF4-FFF2-40B4-BE49-F238E27FC236}">
+                    <a16:creationId xmlns:a16="http://schemas.microsoft.com/office/drawing/2014/main" id="{47F423D6-BF49-F16B-9504-5EEC1CA0F576}"/>
+                  </a:ext>
+                </a:extLst>
+              </p:cNvPr>
+              <p:cNvSpPr txBox="1"/>
+              <p:nvPr/>
+            </p:nvSpPr>
+            <p:spPr>
+              <a:xfrm>
+                <a:off x="583019" y="1524000"/>
+                <a:ext cx="11199971" cy="2800767"/>
+              </a:xfrm>
+              <a:prstGeom prst="rect">
+                <a:avLst/>
+              </a:prstGeom>
+              <a:solidFill>
+                <a:schemeClr val="bg1">
+                  <a:lumMod val="95000"/>
+                </a:schemeClr>
+              </a:solidFill>
+              <a:ln w="28575">
+                <a:solidFill>
+                  <a:srgbClr val="E0700D"/>
+                </a:solidFill>
+              </a:ln>
+            </p:spPr>
+            <p:txBody>
+              <a:bodyPr wrap="square" rtlCol="0">
+                <a:spAutoFit/>
+              </a:bodyPr>
+              <a:lstStyle/>
+              <a:p>
+                <a:pPr algn="just"/>
+                <a:r>
+                  <a:rPr lang="en-US" sz="1200" b="1" i="1" dirty="0">
+                    <a:latin typeface="Arial" panose="020B0604020202020204" pitchFamily="34" charset="0"/>
+                    <a:cs typeface="Arial" panose="020B0604020202020204" pitchFamily="34" charset="0"/>
+                  </a:rPr>
+                  <a:t>Comment results</a:t>
+                </a:r>
+              </a:p>
+              <a:p>
+                <a:pPr algn="just"/>
+                <a:endParaRPr lang="en-US" sz="1200" dirty="0">
+                  <a:latin typeface="Arial" panose="020B0604020202020204" pitchFamily="34" charset="0"/>
+                  <a:cs typeface="Arial" panose="020B0604020202020204" pitchFamily="34" charset="0"/>
+                </a:endParaRPr>
+              </a:p>
+              <a:p>
+                <a:pPr algn="just"/>
+                <a:r>
+                  <a:rPr lang="es-ES" sz="1000" dirty="0">
+                    <a:latin typeface="Arial" panose="020B0604020202020204" pitchFamily="34" charset="0"/>
+                    <a:cs typeface="Arial" panose="020B0604020202020204" pitchFamily="34" charset="0"/>
+                  </a:rPr>
+                  <a:t>En este caso, se ha vuelto a diseñar un acoplador direccional, con la diferencia de que ahora se ha llevado a cabo un barrido con la longitud de onda. Después se ha realizado una simulación de la longitud de acoplo </a:t>
+                </a:r>
+                <a14:m>
+                  <m:oMath xmlns:m="http://schemas.openxmlformats.org/officeDocument/2006/math">
+                    <m:sSub>
+                      <m:sSubPr>
+                        <m:ctrlPr>
+                          <a:rPr lang="ar-AE" sz="1000"/>
+                        </m:ctrlPr>
+                      </m:sSubPr>
+                      <m:e>
+                        <m:r>
+                          <m:rPr>
+                            <m:sty m:val="p"/>
+                          </m:rPr>
+                          <a:rPr lang="ar-AE" sz="1000" b="0" i="0"/>
+                          <m:t>L</m:t>
+                        </m:r>
+                      </m:e>
+                      <m:sub>
+                        <m:r>
+                          <m:rPr>
+                            <m:sty m:val="p"/>
+                          </m:rPr>
+                          <a:rPr lang="ar-AE" sz="1000" b="0" i="0"/>
+                          <m:t>π</m:t>
+                        </m:r>
+                      </m:sub>
+                    </m:sSub>
+                  </m:oMath>
+                </a14:m>
+                <a:r>
+                  <a:rPr lang="ar-AE" sz="1000" dirty="0">
+                    <a:latin typeface="Arial" panose="020B0604020202020204" pitchFamily="34" charset="0"/>
+                    <a:cs typeface="Arial" panose="020B0604020202020204" pitchFamily="34" charset="0"/>
+                  </a:rPr>
+                  <a:t>, </a:t>
+                </a:r>
+                <a:r>
+                  <a:rPr lang="es-ES" sz="1000" dirty="0">
+                    <a:latin typeface="Arial" panose="020B0604020202020204" pitchFamily="34" charset="0"/>
+                    <a:cs typeface="Arial" panose="020B0604020202020204" pitchFamily="34" charset="0"/>
+                  </a:rPr>
+                  <a:t>en función de dichas longitudes de onda.</a:t>
+                </a:r>
+              </a:p>
+              <a:p>
+                <a:pPr algn="just"/>
+                <a:endParaRPr lang="es-ES" sz="1000" dirty="0">
+                  <a:latin typeface="Arial" panose="020B0604020202020204" pitchFamily="34" charset="0"/>
+                  <a:cs typeface="Arial" panose="020B0604020202020204" pitchFamily="34" charset="0"/>
+                </a:endParaRPr>
+              </a:p>
+              <a:p>
+                <a:pPr algn="just"/>
+                <a:r>
+                  <a:rPr lang="es-ES" sz="1000" dirty="0">
+                    <a:latin typeface="Arial" panose="020B0604020202020204" pitchFamily="34" charset="0"/>
+                    <a:cs typeface="Arial" panose="020B0604020202020204" pitchFamily="34" charset="0"/>
+                  </a:rPr>
+                  <a:t>Se observa que, al aumentar la longitud de onda, la longitud de acoplo </a:t>
+                </a:r>
+                <a14:m>
+                  <m:oMath xmlns:m="http://schemas.openxmlformats.org/officeDocument/2006/math">
+                    <m:sSub>
+                      <m:sSubPr>
+                        <m:ctrlPr>
+                          <a:rPr lang="ar-AE" sz="1000"/>
+                        </m:ctrlPr>
+                      </m:sSubPr>
+                      <m:e>
+                        <m:r>
+                          <m:rPr>
+                            <m:sty m:val="p"/>
+                          </m:rPr>
+                          <a:rPr lang="ar-AE" sz="1000" b="0" i="0"/>
+                          <m:t>L</m:t>
+                        </m:r>
+                      </m:e>
+                      <m:sub>
+                        <m:r>
+                          <m:rPr>
+                            <m:sty m:val="p"/>
+                          </m:rPr>
+                          <a:rPr lang="ar-AE" sz="1000" b="0" i="0"/>
+                          <m:t>π</m:t>
+                        </m:r>
+                      </m:sub>
+                    </m:sSub>
+                  </m:oMath>
+                </a14:m>
+                <a:r>
+                  <a:rPr lang="es-ES" sz="1000" dirty="0">
+                    <a:latin typeface="Arial" panose="020B0604020202020204" pitchFamily="34" charset="0"/>
+                    <a:cs typeface="Arial" panose="020B0604020202020204" pitchFamily="34" charset="0"/>
+                  </a:rPr>
+                  <a:t>disminuye porque el campo óptico se extiende más fuera del núcleo, incrementando el solapamiento de los campos evanescentes entre las guías. Como consecuencia, el acoplo entre ellas se vuelve más fuerte.</a:t>
+                </a:r>
+              </a:p>
+              <a:p>
+                <a:pPr algn="just"/>
+                <a:endParaRPr lang="es-ES" sz="1000" dirty="0">
+                  <a:latin typeface="Arial" panose="020B0604020202020204" pitchFamily="34" charset="0"/>
+                  <a:cs typeface="Arial" panose="020B0604020202020204" pitchFamily="34" charset="0"/>
+                </a:endParaRPr>
+              </a:p>
+              <a:p>
+                <a:pPr algn="just"/>
+                <a:r>
+                  <a:rPr lang="es-ES" sz="1000" dirty="0">
+                    <a:latin typeface="Arial" panose="020B0604020202020204" pitchFamily="34" charset="0"/>
+                    <a:cs typeface="Arial" panose="020B0604020202020204" pitchFamily="34" charset="0"/>
+                  </a:rPr>
+                  <a:t>Además, la diferencia entre los índices efectivos de los modos acoplados aumenta, lo que implica, según la expresión de </a:t>
+                </a:r>
+                <a14:m>
+                  <m:oMath xmlns:m="http://schemas.openxmlformats.org/officeDocument/2006/math">
+                    <m:sSub>
+                      <m:sSubPr>
+                        <m:ctrlPr>
+                          <a:rPr lang="ar-AE" sz="1000"/>
+                        </m:ctrlPr>
+                      </m:sSubPr>
+                      <m:e>
+                        <m:r>
+                          <m:rPr>
+                            <m:sty m:val="p"/>
+                          </m:rPr>
+                          <a:rPr lang="ar-AE" sz="1000" b="0" i="0"/>
+                          <m:t>L</m:t>
+                        </m:r>
+                      </m:e>
+                      <m:sub>
+                        <m:r>
+                          <m:rPr>
+                            <m:sty m:val="p"/>
+                          </m:rPr>
+                          <a:rPr lang="ar-AE" sz="1000" b="0" i="0"/>
+                          <m:t>π</m:t>
+                        </m:r>
+                      </m:sub>
+                    </m:sSub>
+                  </m:oMath>
+                </a14:m>
+                <a:r>
+                  <a:rPr lang="ar-AE" sz="1000" dirty="0">
+                    <a:latin typeface="Arial" panose="020B0604020202020204" pitchFamily="34" charset="0"/>
+                    <a:cs typeface="Arial" panose="020B0604020202020204" pitchFamily="34" charset="0"/>
+                  </a:rPr>
+                  <a:t>, </a:t>
+                </a:r>
+                <a:r>
+                  <a:rPr lang="es-ES" sz="1000" dirty="0">
+                    <a:latin typeface="Arial" panose="020B0604020202020204" pitchFamily="34" charset="0"/>
+                    <a:cs typeface="Arial" panose="020B0604020202020204" pitchFamily="34" charset="0"/>
+                  </a:rPr>
+                  <a:t>que se necesita una menor longitud de propagación para transferir completamente la potencia de una guía a la otra.</a:t>
+                </a:r>
+              </a:p>
+              <a:p>
+                <a:pPr algn="just"/>
+                <a:endParaRPr lang="es-ES" sz="1000" dirty="0">
+                  <a:latin typeface="Arial" panose="020B0604020202020204" pitchFamily="34" charset="0"/>
+                  <a:cs typeface="Arial" panose="020B0604020202020204" pitchFamily="34" charset="0"/>
+                </a:endParaRPr>
+              </a:p>
+              <a:p>
+                <a:pPr algn="just"/>
+                <a:r>
+                  <a:rPr lang="es-ES" sz="1000" dirty="0">
+                    <a:latin typeface="Arial" panose="020B0604020202020204" pitchFamily="34" charset="0"/>
+                    <a:cs typeface="Arial" panose="020B0604020202020204" pitchFamily="34" charset="0"/>
+                  </a:rPr>
+                  <a:t>Por tanto, la transferencia de potencia es más rápida y la longitud de acoplo disminuye al aumentar la longitud de onda.</a:t>
+                </a:r>
+              </a:p>
+              <a:p>
+                <a:pPr algn="just"/>
+                <a:endParaRPr lang="es-ES" sz="1000" dirty="0">
+                  <a:latin typeface="Arial" panose="020B0604020202020204" pitchFamily="34" charset="0"/>
+                  <a:cs typeface="Arial" panose="020B0604020202020204" pitchFamily="34" charset="0"/>
+                </a:endParaRPr>
+              </a:p>
+              <a:p>
+                <a:pPr algn="just"/>
+                <a:r>
+                  <a:rPr lang="es-ES" sz="1000" dirty="0">
+                    <a:latin typeface="Arial" panose="020B0604020202020204" pitchFamily="34" charset="0"/>
+                    <a:cs typeface="Arial" panose="020B0604020202020204" pitchFamily="34" charset="0"/>
+                  </a:rPr>
+                  <a:t>Por último, comparando los casos </a:t>
+                </a:r>
+                <a:r>
+                  <a:rPr lang="es-ES" sz="1000" dirty="0" err="1">
+                    <a:latin typeface="Arial" panose="020B0604020202020204" pitchFamily="34" charset="0"/>
+                    <a:cs typeface="Arial" panose="020B0604020202020204" pitchFamily="34" charset="0"/>
+                  </a:rPr>
+                  <a:t>deep</a:t>
+                </a:r>
+                <a:r>
+                  <a:rPr lang="es-ES" sz="1000" dirty="0">
+                    <a:latin typeface="Arial" panose="020B0604020202020204" pitchFamily="34" charset="0"/>
+                    <a:cs typeface="Arial" panose="020B0604020202020204" pitchFamily="34" charset="0"/>
+                  </a:rPr>
+                  <a:t> y </a:t>
+                </a:r>
+                <a:r>
+                  <a:rPr lang="es-ES" sz="1000" dirty="0" err="1">
+                    <a:latin typeface="Arial" panose="020B0604020202020204" pitchFamily="34" charset="0"/>
+                    <a:cs typeface="Arial" panose="020B0604020202020204" pitchFamily="34" charset="0"/>
+                  </a:rPr>
+                  <a:t>shallow</a:t>
+                </a:r>
+                <a:r>
+                  <a:rPr lang="es-ES" sz="1000" dirty="0">
+                    <a:latin typeface="Arial" panose="020B0604020202020204" pitchFamily="34" charset="0"/>
+                    <a:cs typeface="Arial" panose="020B0604020202020204" pitchFamily="34" charset="0"/>
+                  </a:rPr>
+                  <a:t>, se observa que el acoplo es mayor en el caso </a:t>
+                </a:r>
+                <a:r>
+                  <a:rPr lang="es-ES" sz="1000" dirty="0" err="1">
+                    <a:latin typeface="Arial" panose="020B0604020202020204" pitchFamily="34" charset="0"/>
+                    <a:cs typeface="Arial" panose="020B0604020202020204" pitchFamily="34" charset="0"/>
+                  </a:rPr>
+                  <a:t>shallow</a:t>
+                </a:r>
+                <a:r>
+                  <a:rPr lang="es-ES" sz="1000" dirty="0">
+                    <a:latin typeface="Arial" panose="020B0604020202020204" pitchFamily="34" charset="0"/>
+                    <a:cs typeface="Arial" panose="020B0604020202020204" pitchFamily="34" charset="0"/>
+                  </a:rPr>
+                  <a:t> ya que presenta menor </a:t>
+                </a:r>
+                <a14:m>
+                  <m:oMath xmlns:m="http://schemas.openxmlformats.org/officeDocument/2006/math">
+                    <m:sSub>
+                      <m:sSubPr>
+                        <m:ctrlPr>
+                          <a:rPr lang="ar-AE" sz="1000"/>
+                        </m:ctrlPr>
+                      </m:sSubPr>
+                      <m:e>
+                        <m:r>
+                          <m:rPr>
+                            <m:sty m:val="p"/>
+                          </m:rPr>
+                          <a:rPr lang="ar-AE" sz="1000" b="0" i="0"/>
+                          <m:t>L</m:t>
+                        </m:r>
+                      </m:e>
+                      <m:sub>
+                        <m:r>
+                          <m:rPr>
+                            <m:sty m:val="p"/>
+                          </m:rPr>
+                          <a:rPr lang="ar-AE" sz="1000" b="0" i="0"/>
+                          <m:t>π</m:t>
+                        </m:r>
+                      </m:sub>
+                    </m:sSub>
+                  </m:oMath>
+                </a14:m>
+                <a:r>
+                  <a:rPr lang="es-ES" sz="1000" dirty="0">
+                    <a:latin typeface="Arial" panose="020B0604020202020204" pitchFamily="34" charset="0"/>
+                    <a:cs typeface="Arial" panose="020B0604020202020204" pitchFamily="34" charset="0"/>
+                  </a:rPr>
+                  <a:t> debido a que el campo se extiende más fuera del núcleo por la menor confinación, aumentando el solapamiento entre las guías. En el caso </a:t>
+                </a:r>
+                <a:r>
+                  <a:rPr lang="es-ES" sz="1000" dirty="0" err="1">
+                    <a:latin typeface="Arial" panose="020B0604020202020204" pitchFamily="34" charset="0"/>
+                    <a:cs typeface="Arial" panose="020B0604020202020204" pitchFamily="34" charset="0"/>
+                  </a:rPr>
+                  <a:t>deep</a:t>
+                </a:r>
+                <a:r>
+                  <a:rPr lang="es-ES" sz="1000" dirty="0">
+                    <a:latin typeface="Arial" panose="020B0604020202020204" pitchFamily="34" charset="0"/>
+                    <a:cs typeface="Arial" panose="020B0604020202020204" pitchFamily="34" charset="0"/>
+                  </a:rPr>
+                  <a:t>, el confinamiento es mayor, el acoplo es más débil y los valores de </a:t>
+                </a:r>
+                <a14:m>
+                  <m:oMath xmlns:m="http://schemas.openxmlformats.org/officeDocument/2006/math">
+                    <m:sSub>
+                      <m:sSubPr>
+                        <m:ctrlPr>
+                          <a:rPr lang="ar-AE" sz="1000"/>
+                        </m:ctrlPr>
+                      </m:sSubPr>
+                      <m:e>
+                        <m:r>
+                          <m:rPr>
+                            <m:sty m:val="p"/>
+                          </m:rPr>
+                          <a:rPr lang="ar-AE" sz="1000" b="0" i="0"/>
+                          <m:t>L</m:t>
+                        </m:r>
+                      </m:e>
+                      <m:sub>
+                        <m:r>
+                          <m:rPr>
+                            <m:sty m:val="p"/>
+                          </m:rPr>
+                          <a:rPr lang="ar-AE" sz="1000" b="0" i="0"/>
+                          <m:t>π</m:t>
+                        </m:r>
+                      </m:sub>
+                    </m:sSub>
+                  </m:oMath>
+                </a14:m>
+                <a:r>
+                  <a:rPr lang="es-ES" sz="1000" dirty="0">
+                    <a:latin typeface="Arial" panose="020B0604020202020204" pitchFamily="34" charset="0"/>
+                    <a:cs typeface="Arial" panose="020B0604020202020204" pitchFamily="34" charset="0"/>
+                  </a:rPr>
+                  <a:t>son más altos. Además, el caso </a:t>
+                </a:r>
+                <a:r>
+                  <a:rPr lang="es-ES" sz="1000" dirty="0" err="1">
+                    <a:latin typeface="Arial" panose="020B0604020202020204" pitchFamily="34" charset="0"/>
+                    <a:cs typeface="Arial" panose="020B0604020202020204" pitchFamily="34" charset="0"/>
+                  </a:rPr>
+                  <a:t>shallow</a:t>
+                </a:r>
+                <a:r>
+                  <a:rPr lang="es-ES" sz="1000" dirty="0">
+                    <a:latin typeface="Arial" panose="020B0604020202020204" pitchFamily="34" charset="0"/>
+                    <a:cs typeface="Arial" panose="020B0604020202020204" pitchFamily="34" charset="0"/>
+                  </a:rPr>
+                  <a:t> presenta una respuesta más suave frente a variaciones de longitud de onda, lo que lo hace más robusto que la Deep frente a cambios en dicho parámetro.</a:t>
+                </a:r>
+                <a:endParaRPr lang="en-US" sz="1000" dirty="0">
+                  <a:latin typeface="Arial" panose="020B0604020202020204" pitchFamily="34" charset="0"/>
+                  <a:cs typeface="Arial" panose="020B0604020202020204" pitchFamily="34" charset="0"/>
+                </a:endParaRPr>
+              </a:p>
+              <a:p>
+                <a:pPr algn="just"/>
+                <a:endParaRPr lang="en-US" sz="1200" dirty="0">
+                  <a:latin typeface="Arial" panose="020B0604020202020204" pitchFamily="34" charset="0"/>
+                  <a:cs typeface="Arial" panose="020B0604020202020204" pitchFamily="34" charset="0"/>
+                </a:endParaRPr>
+              </a:p>
+            </p:txBody>
+          </p:sp>
+        </mc:Choice>
+        <mc:Fallback>
+          <p:sp>
+            <p:nvSpPr>
+              <p:cNvPr id="2" name="CuadroTexto 1">
+                <a:extLst>
+                  <a:ext uri="{FF2B5EF4-FFF2-40B4-BE49-F238E27FC236}">
+                    <a16:creationId xmlns:a16="http://schemas.microsoft.com/office/drawing/2014/main" id="{47F423D6-BF49-F16B-9504-5EEC1CA0F576}"/>
+                  </a:ext>
+                </a:extLst>
+              </p:cNvPr>
+              <p:cNvSpPr txBox="1">
+                <a:spLocks noRot="1" noChangeAspect="1" noMove="1" noResize="1" noEditPoints="1" noAdjustHandles="1" noChangeArrowheads="1" noChangeShapeType="1" noTextEdit="1"/>
+              </p:cNvSpPr>
+              <p:nvPr/>
+            </p:nvSpPr>
+            <p:spPr>
+              <a:xfrm>
+                <a:off x="583019" y="1524000"/>
+                <a:ext cx="11199971" cy="2800767"/>
+              </a:xfrm>
+              <a:prstGeom prst="rect">
+                <a:avLst/>
+              </a:prstGeom>
+              <a:blipFill>
+                <a:blip r:embed="rId4"/>
+                <a:stretch>
+                  <a:fillRect/>
+                </a:stretch>
+              </a:blipFill>
+              <a:ln w="28575">
+                <a:solidFill>
+                  <a:srgbClr val="E0700D"/>
+                </a:solidFill>
+              </a:ln>
+            </p:spPr>
+            <p:txBody>
+              <a:bodyPr/>
+              <a:lstStyle/>
+              <a:p>
+                <a:r>
+                  <a:rPr lang="es-ES">
+                    <a:noFill/>
+                  </a:rPr>
+                  <a:t> </a:t>
+                </a:r>
+              </a:p>
+            </p:txBody>
+          </p:sp>
+        </mc:Fallback>
+      </mc:AlternateContent>
+    </p:spTree>
+    <p:extLst>
+      <p:ext uri="{BB962C8B-B14F-4D97-AF65-F5344CB8AC3E}">
+        <p14:creationId xmlns:p14="http://schemas.microsoft.com/office/powerpoint/2010/main" val="5043272"/>
+      </p:ext>
+    </p:extLst>
+  </p:cSld>
+  <p:clrMapOvr>
+    <a:masterClrMapping/>
+  </p:clrMapOvr>
+</p:sld>
+</file>
+
+<file path=ppt/slides/slide28.xml><?xml version="1.0" encoding="utf-8"?>
 <p:sld xmlns:a="http://schemas.openxmlformats.org/drawingml/2006/main" xmlns:r="http://schemas.openxmlformats.org/officeDocument/2006/relationships" xmlns:p="http://schemas.openxmlformats.org/presentationml/2006/main">
   <p:cSld>
     <p:spTree>
@@ -17935,7 +19360,7 @@
           <a:p>
             <a:fld id="{B6F15528-21DE-4FAA-801E-634DDDAF4B2B}" type="slidenum">
               <a:rPr lang="es-ES" smtClean="0"/>
-              <a:t>26</a:t>
+              <a:t>28</a:t>
             </a:fld>
             <a:endParaRPr lang="es-ES"/>
           </a:p>
@@ -18162,42 +19587,6 @@
           </a:p>
         </p:txBody>
       </p:sp>
-      <p:sp>
-        <p:nvSpPr>
-          <p:cNvPr id="6" name="CuadroTexto 5">
-            <a:extLst>
-              <a:ext uri="{FF2B5EF4-FFF2-40B4-BE49-F238E27FC236}">
-                <a16:creationId xmlns:a16="http://schemas.microsoft.com/office/drawing/2014/main" id="{0C016548-01A2-6E58-B80D-148384B98EB3}"/>
-              </a:ext>
-            </a:extLst>
-          </p:cNvPr>
-          <p:cNvSpPr txBox="1"/>
-          <p:nvPr/>
-        </p:nvSpPr>
-        <p:spPr>
-          <a:xfrm>
-            <a:off x="6331152" y="4342178"/>
-            <a:ext cx="2269787" cy="369332"/>
-          </a:xfrm>
-          <a:prstGeom prst="rect">
-            <a:avLst/>
-          </a:prstGeom>
-          <a:noFill/>
-        </p:spPr>
-        <p:txBody>
-          <a:bodyPr wrap="square">
-            <a:spAutoFit/>
-          </a:bodyPr>
-          <a:lstStyle/>
-          <a:p>
-            <a:r>
-              <a:rPr lang="en-US" dirty="0"/>
-              <a:t>slab = 150nm</a:t>
-            </a:r>
-            <a:endParaRPr lang="es-ES" dirty="0"/>
-          </a:p>
-        </p:txBody>
-      </p:sp>
       <mc:AlternateContent xmlns:mc="http://schemas.openxmlformats.org/markup-compatibility/2006" xmlns:a14="http://schemas.microsoft.com/office/drawing/2010/main">
         <mc:Choice Requires="a14">
           <p:sp>
@@ -18478,6 +19867,67 @@
           </p:sp>
         </mc:Fallback>
       </mc:AlternateContent>
+      <p:pic>
+        <p:nvPicPr>
+          <p:cNvPr id="8" name="Imagen 7">
+            <a:extLst>
+              <a:ext uri="{FF2B5EF4-FFF2-40B4-BE49-F238E27FC236}">
+                <a16:creationId xmlns:a16="http://schemas.microsoft.com/office/drawing/2014/main" id="{BA25E939-8302-DF96-BBAA-1F5765ECB437}"/>
+              </a:ext>
+            </a:extLst>
+          </p:cNvPr>
+          <p:cNvPicPr>
+            <a:picLocks noChangeAspect="1"/>
+          </p:cNvPicPr>
+          <p:nvPr/>
+        </p:nvPicPr>
+        <p:blipFill>
+          <a:blip r:embed="rId7"/>
+          <a:srcRect t="2221"/>
+          <a:stretch>
+            <a:fillRect/>
+          </a:stretch>
+        </p:blipFill>
+        <p:spPr>
+          <a:xfrm>
+            <a:off x="762638" y="1617862"/>
+            <a:ext cx="5190531" cy="2965904"/>
+          </a:xfrm>
+          <a:prstGeom prst="rect">
+            <a:avLst/>
+          </a:prstGeom>
+        </p:spPr>
+      </p:pic>
+      <p:pic>
+        <p:nvPicPr>
+          <p:cNvPr id="12" name="Imagen 11">
+            <a:extLst>
+              <a:ext uri="{FF2B5EF4-FFF2-40B4-BE49-F238E27FC236}">
+                <a16:creationId xmlns:a16="http://schemas.microsoft.com/office/drawing/2014/main" id="{F93A7FA9-C5A6-DF2A-1516-B3C2139CC821}"/>
+              </a:ext>
+            </a:extLst>
+          </p:cNvPr>
+          <p:cNvPicPr>
+            <a:picLocks noChangeAspect="1"/>
+          </p:cNvPicPr>
+          <p:nvPr/>
+        </p:nvPicPr>
+        <p:blipFill>
+          <a:blip r:embed="rId8"/>
+          <a:stretch>
+            <a:fillRect/>
+          </a:stretch>
+        </p:blipFill>
+        <p:spPr>
+          <a:xfrm>
+            <a:off x="6578859" y="1592639"/>
+            <a:ext cx="5155647" cy="3016350"/>
+          </a:xfrm>
+          <a:prstGeom prst="rect">
+            <a:avLst/>
+          </a:prstGeom>
+        </p:spPr>
+      </p:pic>
     </p:spTree>
     <p:extLst>
       <p:ext uri="{BB962C8B-B14F-4D97-AF65-F5344CB8AC3E}">
@@ -18491,7 +19941,7 @@
 </p:sld>
 </file>
 
-<file path=ppt/slides/slide27.xml><?xml version="1.0" encoding="utf-8"?>
+<file path=ppt/slides/slide29.xml><?xml version="1.0" encoding="utf-8"?>
 <p:sld xmlns:a="http://schemas.openxmlformats.org/drawingml/2006/main" xmlns:r="http://schemas.openxmlformats.org/officeDocument/2006/relationships" xmlns:p="http://schemas.openxmlformats.org/presentationml/2006/main">
   <p:cSld>
     <p:spTree>
@@ -18641,7 +20091,7 @@
           <a:p>
             <a:fld id="{B6F15528-21DE-4FAA-801E-634DDDAF4B2B}" type="slidenum">
               <a:rPr lang="es-ES" smtClean="0"/>
-              <a:t>27</a:t>
+              <a:t>29</a:t>
             </a:fld>
             <a:endParaRPr lang="es-ES"/>
           </a:p>
@@ -18875,42 +20325,6 @@
           </a:p>
         </p:txBody>
       </p:sp>
-      <p:sp>
-        <p:nvSpPr>
-          <p:cNvPr id="6" name="CuadroTexto 5">
-            <a:extLst>
-              <a:ext uri="{FF2B5EF4-FFF2-40B4-BE49-F238E27FC236}">
-                <a16:creationId xmlns:a16="http://schemas.microsoft.com/office/drawing/2014/main" id="{154B5534-E510-6404-1E30-B73FDF73AD42}"/>
-              </a:ext>
-            </a:extLst>
-          </p:cNvPr>
-          <p:cNvSpPr txBox="1"/>
-          <p:nvPr/>
-        </p:nvSpPr>
-        <p:spPr>
-          <a:xfrm>
-            <a:off x="6331152" y="4342178"/>
-            <a:ext cx="2269787" cy="369332"/>
-          </a:xfrm>
-          <a:prstGeom prst="rect">
-            <a:avLst/>
-          </a:prstGeom>
-          <a:noFill/>
-        </p:spPr>
-        <p:txBody>
-          <a:bodyPr wrap="square">
-            <a:spAutoFit/>
-          </a:bodyPr>
-          <a:lstStyle/>
-          <a:p>
-            <a:r>
-              <a:rPr lang="en-US" dirty="0"/>
-              <a:t>slab = 150nm</a:t>
-            </a:r>
-            <a:endParaRPr lang="es-ES" dirty="0"/>
-          </a:p>
-        </p:txBody>
-      </p:sp>
       <mc:AlternateContent xmlns:mc="http://schemas.openxmlformats.org/markup-compatibility/2006" xmlns:a14="http://schemas.microsoft.com/office/drawing/2010/main">
         <mc:Choice Requires="a14">
           <p:sp>
@@ -19175,6 +20589,66 @@
           </p:sp>
         </mc:Fallback>
       </mc:AlternateContent>
+      <p:pic>
+        <p:nvPicPr>
+          <p:cNvPr id="8" name="Imagen 7">
+            <a:extLst>
+              <a:ext uri="{FF2B5EF4-FFF2-40B4-BE49-F238E27FC236}">
+                <a16:creationId xmlns:a16="http://schemas.microsoft.com/office/drawing/2014/main" id="{B802B6FA-71DA-4593-A6D6-F093940F1C7D}"/>
+              </a:ext>
+            </a:extLst>
+          </p:cNvPr>
+          <p:cNvPicPr>
+            <a:picLocks noChangeAspect="1"/>
+          </p:cNvPicPr>
+          <p:nvPr/>
+        </p:nvPicPr>
+        <p:blipFill>
+          <a:blip r:embed="rId7"/>
+          <a:stretch>
+            <a:fillRect/>
+          </a:stretch>
+        </p:blipFill>
+        <p:spPr>
+          <a:xfrm>
+            <a:off x="914400" y="1614914"/>
+            <a:ext cx="5117123" cy="2971800"/>
+          </a:xfrm>
+          <a:prstGeom prst="rect">
+            <a:avLst/>
+          </a:prstGeom>
+        </p:spPr>
+      </p:pic>
+      <p:pic>
+        <p:nvPicPr>
+          <p:cNvPr id="12" name="Imagen 11">
+            <a:extLst>
+              <a:ext uri="{FF2B5EF4-FFF2-40B4-BE49-F238E27FC236}">
+                <a16:creationId xmlns:a16="http://schemas.microsoft.com/office/drawing/2014/main" id="{7DE0037C-FE91-C3C4-3F74-D707078E978A}"/>
+              </a:ext>
+            </a:extLst>
+          </p:cNvPr>
+          <p:cNvPicPr>
+            <a:picLocks noChangeAspect="1"/>
+          </p:cNvPicPr>
+          <p:nvPr/>
+        </p:nvPicPr>
+        <p:blipFill>
+          <a:blip r:embed="rId8"/>
+          <a:stretch>
+            <a:fillRect/>
+          </a:stretch>
+        </p:blipFill>
+        <p:spPr>
+          <a:xfrm>
+            <a:off x="6506141" y="1613012"/>
+            <a:ext cx="5117123" cy="2973702"/>
+          </a:xfrm>
+          <a:prstGeom prst="rect">
+            <a:avLst/>
+          </a:prstGeom>
+        </p:spPr>
+      </p:pic>
     </p:spTree>
     <p:extLst>
       <p:ext uri="{BB962C8B-B14F-4D97-AF65-F5344CB8AC3E}">
@@ -19188,7 +20662,142 @@
 </p:sld>
 </file>
 
-<file path=ppt/slides/slide28.xml><?xml version="1.0" encoding="utf-8"?>
+<file path=ppt/slides/slide3.xml><?xml version="1.0" encoding="utf-8"?>
+<p:sld xmlns:a="http://schemas.openxmlformats.org/drawingml/2006/main" xmlns:r="http://schemas.openxmlformats.org/officeDocument/2006/relationships" xmlns:p="http://schemas.openxmlformats.org/presentationml/2006/main">
+  <p:cSld>
+    <p:spTree>
+      <p:nvGrpSpPr>
+        <p:cNvPr id="1" name=""/>
+        <p:cNvGrpSpPr/>
+        <p:nvPr/>
+      </p:nvGrpSpPr>
+      <p:grpSpPr>
+        <a:xfrm>
+          <a:off x="0" y="0"/>
+          <a:ext cx="0" cy="0"/>
+          <a:chOff x="0" y="0"/>
+          <a:chExt cx="0" cy="0"/>
+        </a:xfrm>
+      </p:grpSpPr>
+      <p:sp>
+        <p:nvSpPr>
+          <p:cNvPr id="4" name="Marcador de pie de página 3">
+            <a:extLst>
+              <a:ext uri="{FF2B5EF4-FFF2-40B4-BE49-F238E27FC236}">
+                <a16:creationId xmlns:a16="http://schemas.microsoft.com/office/drawing/2014/main" id="{1F74687F-7302-3F32-F9D1-0566D05F33AE}"/>
+              </a:ext>
+            </a:extLst>
+          </p:cNvPr>
+          <p:cNvSpPr>
+            <a:spLocks noGrp="1"/>
+          </p:cNvSpPr>
+          <p:nvPr>
+            <p:ph type="ftr" sz="quarter" idx="5"/>
+          </p:nvPr>
+        </p:nvSpPr>
+        <p:spPr/>
+        <p:txBody>
+          <a:bodyPr/>
+          <a:lstStyle/>
+          <a:p>
+            <a:pPr marL="12700">
+              <a:spcBef>
+                <a:spcPts val="15"/>
+              </a:spcBef>
+            </a:pPr>
+            <a:r>
+              <a:rPr lang="es-ES" spc="-5"/>
+              <a:t>LAB 2.0. COUPLERS</a:t>
+            </a:r>
+            <a:endParaRPr lang="es-ES" spc="-5" dirty="0"/>
+          </a:p>
+        </p:txBody>
+      </p:sp>
+      <p:sp>
+        <p:nvSpPr>
+          <p:cNvPr id="5" name="Marcador de número de diapositiva 4">
+            <a:extLst>
+              <a:ext uri="{FF2B5EF4-FFF2-40B4-BE49-F238E27FC236}">
+                <a16:creationId xmlns:a16="http://schemas.microsoft.com/office/drawing/2014/main" id="{78335A49-ACE2-C055-50CA-8DD755D2E76D}"/>
+              </a:ext>
+            </a:extLst>
+          </p:cNvPr>
+          <p:cNvSpPr>
+            <a:spLocks noGrp="1"/>
+          </p:cNvSpPr>
+          <p:nvPr>
+            <p:ph type="sldNum" sz="quarter" idx="7"/>
+          </p:nvPr>
+        </p:nvSpPr>
+        <p:spPr/>
+        <p:txBody>
+          <a:bodyPr/>
+          <a:lstStyle/>
+          <a:p>
+            <a:fld id="{B6F15528-21DE-4FAA-801E-634DDDAF4B2B}" type="slidenum">
+              <a:rPr lang="es-ES" smtClean="0"/>
+              <a:t>3</a:t>
+            </a:fld>
+            <a:endParaRPr lang="es-ES"/>
+          </a:p>
+        </p:txBody>
+      </p:sp>
+      <p:sp>
+        <p:nvSpPr>
+          <p:cNvPr id="6" name="Título 4">
+            <a:extLst>
+              <a:ext uri="{FF2B5EF4-FFF2-40B4-BE49-F238E27FC236}">
+                <a16:creationId xmlns:a16="http://schemas.microsoft.com/office/drawing/2014/main" id="{AF6692CA-D0D0-2BAF-E673-933E02AE2BB8}"/>
+              </a:ext>
+            </a:extLst>
+          </p:cNvPr>
+          <p:cNvSpPr>
+            <a:spLocks noGrp="1"/>
+          </p:cNvSpPr>
+          <p:nvPr>
+            <p:ph type="body" idx="1"/>
+          </p:nvPr>
+        </p:nvSpPr>
+        <p:spPr>
+          <a:xfrm>
+            <a:off x="609600" y="2152650"/>
+            <a:ext cx="10972800" cy="430887"/>
+          </a:xfrm>
+        </p:spPr>
+        <p:txBody>
+          <a:bodyPr/>
+          <a:lstStyle/>
+          <a:p>
+            <a:pPr algn="ctr"/>
+            <a:r>
+              <a:rPr lang="en-US" sz="2800" b="1" dirty="0">
+                <a:effectLst>
+                  <a:outerShdw blurRad="38100" dist="38100" dir="2700000" algn="tl">
+                    <a:srgbClr val="000000">
+                      <a:alpha val="43137"/>
+                    </a:srgbClr>
+                  </a:outerShdw>
+                </a:effectLst>
+              </a:rPr>
+              <a:t>Directional coupler</a:t>
+            </a:r>
+          </a:p>
+        </p:txBody>
+      </p:sp>
+    </p:spTree>
+    <p:extLst>
+      <p:ext uri="{BB962C8B-B14F-4D97-AF65-F5344CB8AC3E}">
+        <p14:creationId xmlns:p14="http://schemas.microsoft.com/office/powerpoint/2010/main" val="1640019522"/>
+      </p:ext>
+    </p:extLst>
+  </p:cSld>
+  <p:clrMapOvr>
+    <a:masterClrMapping/>
+  </p:clrMapOvr>
+</p:sld>
+</file>
+
+<file path=ppt/slides/slide30.xml><?xml version="1.0" encoding="utf-8"?>
 <p:sld xmlns:a="http://schemas.openxmlformats.org/drawingml/2006/main" xmlns:r="http://schemas.openxmlformats.org/officeDocument/2006/relationships" xmlns:p="http://schemas.openxmlformats.org/presentationml/2006/main">
   <p:cSld>
     <p:spTree>
@@ -19327,148 +20936,13 @@
           <a:p>
             <a:fld id="{B6F15528-21DE-4FAA-801E-634DDDAF4B2B}" type="slidenum">
               <a:rPr lang="es-ES" smtClean="0"/>
-              <a:t>28</a:t>
+              <a:t>30</a:t>
             </a:fld>
             <a:endParaRPr lang="es-ES"/>
           </a:p>
         </p:txBody>
       </p:sp>
     </p:spTree>
-  </p:cSld>
-  <p:clrMapOvr>
-    <a:masterClrMapping/>
-  </p:clrMapOvr>
-</p:sld>
-</file>
-
-<file path=ppt/slides/slide3.xml><?xml version="1.0" encoding="utf-8"?>
-<p:sld xmlns:a="http://schemas.openxmlformats.org/drawingml/2006/main" xmlns:r="http://schemas.openxmlformats.org/officeDocument/2006/relationships" xmlns:p="http://schemas.openxmlformats.org/presentationml/2006/main">
-  <p:cSld>
-    <p:spTree>
-      <p:nvGrpSpPr>
-        <p:cNvPr id="1" name=""/>
-        <p:cNvGrpSpPr/>
-        <p:nvPr/>
-      </p:nvGrpSpPr>
-      <p:grpSpPr>
-        <a:xfrm>
-          <a:off x="0" y="0"/>
-          <a:ext cx="0" cy="0"/>
-          <a:chOff x="0" y="0"/>
-          <a:chExt cx="0" cy="0"/>
-        </a:xfrm>
-      </p:grpSpPr>
-      <p:sp>
-        <p:nvSpPr>
-          <p:cNvPr id="4" name="Marcador de pie de página 3">
-            <a:extLst>
-              <a:ext uri="{FF2B5EF4-FFF2-40B4-BE49-F238E27FC236}">
-                <a16:creationId xmlns:a16="http://schemas.microsoft.com/office/drawing/2014/main" id="{1F74687F-7302-3F32-F9D1-0566D05F33AE}"/>
-              </a:ext>
-            </a:extLst>
-          </p:cNvPr>
-          <p:cNvSpPr>
-            <a:spLocks noGrp="1"/>
-          </p:cNvSpPr>
-          <p:nvPr>
-            <p:ph type="ftr" sz="quarter" idx="5"/>
-          </p:nvPr>
-        </p:nvSpPr>
-        <p:spPr/>
-        <p:txBody>
-          <a:bodyPr/>
-          <a:lstStyle/>
-          <a:p>
-            <a:pPr marL="12700">
-              <a:spcBef>
-                <a:spcPts val="15"/>
-              </a:spcBef>
-            </a:pPr>
-            <a:r>
-              <a:rPr lang="es-ES" spc="-5"/>
-              <a:t>LAB 2.0. COUPLERS</a:t>
-            </a:r>
-            <a:endParaRPr lang="es-ES" spc="-5" dirty="0"/>
-          </a:p>
-        </p:txBody>
-      </p:sp>
-      <p:sp>
-        <p:nvSpPr>
-          <p:cNvPr id="5" name="Marcador de número de diapositiva 4">
-            <a:extLst>
-              <a:ext uri="{FF2B5EF4-FFF2-40B4-BE49-F238E27FC236}">
-                <a16:creationId xmlns:a16="http://schemas.microsoft.com/office/drawing/2014/main" id="{78335A49-ACE2-C055-50CA-8DD755D2E76D}"/>
-              </a:ext>
-            </a:extLst>
-          </p:cNvPr>
-          <p:cNvSpPr>
-            <a:spLocks noGrp="1"/>
-          </p:cNvSpPr>
-          <p:nvPr>
-            <p:ph type="sldNum" sz="quarter" idx="7"/>
-          </p:nvPr>
-        </p:nvSpPr>
-        <p:spPr/>
-        <p:txBody>
-          <a:bodyPr/>
-          <a:lstStyle/>
-          <a:p>
-            <a:fld id="{B6F15528-21DE-4FAA-801E-634DDDAF4B2B}" type="slidenum">
-              <a:rPr lang="es-ES" smtClean="0"/>
-              <a:t>3</a:t>
-            </a:fld>
-            <a:endParaRPr lang="es-ES"/>
-          </a:p>
-        </p:txBody>
-      </p:sp>
-      <p:sp>
-        <p:nvSpPr>
-          <p:cNvPr id="6" name="Título 4">
-            <a:extLst>
-              <a:ext uri="{FF2B5EF4-FFF2-40B4-BE49-F238E27FC236}">
-                <a16:creationId xmlns:a16="http://schemas.microsoft.com/office/drawing/2014/main" id="{AF6692CA-D0D0-2BAF-E673-933E02AE2BB8}"/>
-              </a:ext>
-            </a:extLst>
-          </p:cNvPr>
-          <p:cNvSpPr>
-            <a:spLocks noGrp="1"/>
-          </p:cNvSpPr>
-          <p:nvPr>
-            <p:ph type="body" idx="1"/>
-          </p:nvPr>
-        </p:nvSpPr>
-        <p:spPr>
-          <a:xfrm>
-            <a:off x="609600" y="2152650"/>
-            <a:ext cx="10972800" cy="430887"/>
-          </a:xfrm>
-        </p:spPr>
-        <p:txBody>
-          <a:bodyPr/>
-          <a:lstStyle/>
-          <a:p>
-            <a:pPr algn="ctr"/>
-            <a:r>
-              <a:rPr lang="en-US" sz="2800" b="1" dirty="0">
-                <a:effectLst>
-                  <a:outerShdw blurRad="38100" dist="38100" dir="2700000" algn="tl">
-                    <a:srgbClr val="000000">
-                      <a:alpha val="43137"/>
-                    </a:srgbClr>
-                  </a:outerShdw>
-                </a:effectLst>
-              </a:rPr>
-              <a:t>Directional coupler</a:t>
-            </a:r>
-          </a:p>
-        </p:txBody>
-      </p:sp>
-    </p:spTree>
-    <p:extLst>
-      <p:ext uri="{BB962C8B-B14F-4D97-AF65-F5344CB8AC3E}">
-        <p14:creationId xmlns:p14="http://schemas.microsoft.com/office/powerpoint/2010/main" val="1640019522"/>
-      </p:ext>
-    </p:extLst>
   </p:cSld>
   <p:clrMapOvr>
     <a:masterClrMapping/>

</xml_diff>